<commit_message>
docs: update presentation with print-friendly clean white layout, simple English, and companion landscape printout PDF
</commit_message>
<xml_diff>
--- a/APPS_Mini_Project_Presentation.pptx
+++ b/APPS_Mini_Project_Presentation.pptx
@@ -3112,7 +3112,7 @@
             <a:avLst/>
           </a:prstGeom>
           <a:solidFill>
-            <a:srgbClr val="0F172A"/>
+            <a:srgbClr val="FFFFFF"/>
           </a:solidFill>
           <a:ln>
             <a:noFill/>
@@ -3148,18 +3148,18 @@
         </p:nvSpPr>
         <p:spPr>
           <a:xfrm>
-            <a:off x="914400" y="731520"/>
-            <a:ext cx="3840480" cy="411480"/>
+            <a:off x="548640" y="457200"/>
+            <a:ext cx="11094415" cy="5943600"/>
           </a:xfrm>
           <a:prstGeom prst="roundRect">
             <a:avLst/>
           </a:prstGeom>
           <a:solidFill>
-            <a:srgbClr val="1E3A8A"/>
-          </a:solidFill>
-          <a:ln>
+            <a:srgbClr val="FFFFFF"/>
+          </a:solidFill>
+          <a:ln w="25400">
             <a:solidFill>
-              <a:srgbClr val="2563EB"/>
+              <a:srgbClr val="1D4ED8"/>
             </a:solidFill>
           </a:ln>
         </p:spPr>
@@ -3181,92 +3181,30 @@
           <a:bodyPr rtlCol="0" anchor="ctr"/>
           <a:lstStyle/>
           <a:p>
-            <a:pPr algn="ctr">
-              <a:defRPr sz="1100" b="1">
-                <a:solidFill>
-                  <a:srgbClr val="93C5FD"/>
-                </a:solidFill>
-                <a:latin typeface="Calibri"/>
-              </a:defRPr>
-            </a:pPr>
-            <a:r>
-              <a:t>FINAL YEAR MINI PROJECT PRESENTATION</a:t>
-            </a:r>
-          </a:p>
-        </p:txBody>
-      </p:sp>
-      <p:sp>
-        <p:nvSpPr>
-          <p:cNvPr id="4" name="TextBox 3"/>
-          <p:cNvSpPr txBox="1"/>
-          <p:nvPr/>
-        </p:nvSpPr>
-        <p:spPr>
-          <a:xfrm>
-            <a:off x="914400" y="1280160"/>
-            <a:ext cx="10362895" cy="1645920"/>
-          </a:xfrm>
-          <a:prstGeom prst="rect">
-            <a:avLst/>
-          </a:prstGeom>
-          <a:noFill/>
-        </p:spPr>
-        <p:txBody>
-          <a:bodyPr wrap="square">
-            <a:spAutoFit/>
-          </a:bodyPr>
-          <a:lstStyle/>
-          <a:p>
-            <a:pPr algn="l">
-              <a:defRPr sz="2800" b="1">
-                <a:solidFill>
-                  <a:srgbClr val="FFFFFF"/>
-                </a:solidFill>
-                <a:latin typeface="Calibri"/>
-              </a:defRPr>
-            </a:pPr>
-            <a:r>
-              <a:t>AI PREDICTIVE PERSONNEL STRESS AND WELFARE MONITORING SYSTEMS</a:t>
-            </a:r>
-          </a:p>
-          <a:p>
-            <a:pPr>
-              <a:spcBef>
-                <a:spcPts val="800"/>
-              </a:spcBef>
-              <a:defRPr sz="1400">
-                <a:solidFill>
-                  <a:srgbClr val="94A3B8"/>
-                </a:solidFill>
-                <a:latin typeface="Calibri"/>
-              </a:defRPr>
-            </a:pPr>
-            <a:r>
-              <a:t>A Behavioral Telemetry &amp; Clinical AI Early-Warning Triage Platform for Armed Forces</a:t>
-            </a:r>
-          </a:p>
-        </p:txBody>
-      </p:sp>
-      <p:sp>
-        <p:nvSpPr>
-          <p:cNvPr id="5" name="Rounded Rectangle 4"/>
+            <a:pPr algn="ctr"/>
+          </a:p>
+        </p:txBody>
+      </p:sp>
+      <p:sp>
+        <p:nvSpPr>
+          <p:cNvPr id="4" name="Rounded Rectangle 3"/>
           <p:cNvSpPr/>
           <p:nvPr/>
         </p:nvSpPr>
         <p:spPr>
           <a:xfrm>
-            <a:off x="914400" y="3291840"/>
-            <a:ext cx="10362895" cy="2651760"/>
+            <a:off x="914400" y="731520"/>
+            <a:ext cx="4114800" cy="384048"/>
           </a:xfrm>
           <a:prstGeom prst="roundRect">
             <a:avLst/>
           </a:prstGeom>
           <a:solidFill>
-            <a:srgbClr val="1E293B"/>
-          </a:solidFill>
-          <a:ln w="19050">
+            <a:srgbClr val="EFF6FF"/>
+          </a:solidFill>
+          <a:ln>
             <a:solidFill>
-              <a:srgbClr val="2563EB"/>
+              <a:srgbClr val="1D4ED8"/>
             </a:solidFill>
           </a:ln>
         </p:spPr>
@@ -3285,22 +3223,129 @@
           </a:fontRef>
         </p:style>
         <p:txBody>
+          <a:bodyPr rtlCol="0" anchor="ctr"/>
+          <a:lstStyle/>
+          <a:p>
+            <a:pPr algn="ctr">
+              <a:defRPr sz="1100" b="1">
+                <a:solidFill>
+                  <a:srgbClr val="1D4ED8"/>
+                </a:solidFill>
+                <a:latin typeface="Arial"/>
+              </a:defRPr>
+            </a:pPr>
+            <a:r>
+              <a:t>FINAL YEAR MINI PROJECT PRESENTATION</a:t>
+            </a:r>
+          </a:p>
+        </p:txBody>
+      </p:sp>
+      <p:sp>
+        <p:nvSpPr>
+          <p:cNvPr id="5" name="TextBox 4"/>
+          <p:cNvSpPr txBox="1"/>
+          <p:nvPr/>
+        </p:nvSpPr>
+        <p:spPr>
+          <a:xfrm>
+            <a:off x="914400" y="1234440"/>
+            <a:ext cx="10362895" cy="1554480"/>
+          </a:xfrm>
+          <a:prstGeom prst="rect">
+            <a:avLst/>
+          </a:prstGeom>
+          <a:noFill/>
+        </p:spPr>
+        <p:txBody>
+          <a:bodyPr wrap="square">
+            <a:spAutoFit/>
+          </a:bodyPr>
+          <a:lstStyle/>
+          <a:p>
+            <a:pPr algn="l">
+              <a:defRPr sz="2600" b="1">
+                <a:solidFill>
+                  <a:srgbClr val="0F172A"/>
+                </a:solidFill>
+                <a:latin typeface="Arial"/>
+              </a:defRPr>
+            </a:pPr>
+            <a:r>
+              <a:t>AI PREDICTIVE PERSONNEL STRESS AND WELFARE MONITORING SYSTEMS</a:t>
+            </a:r>
+          </a:p>
+          <a:p>
+            <a:pPr>
+              <a:spcBef>
+                <a:spcPts val="600"/>
+              </a:spcBef>
+              <a:defRPr sz="1300" b="1">
+                <a:solidFill>
+                  <a:srgbClr val="0F766E"/>
+                </a:solidFill>
+                <a:latin typeface="Arial"/>
+              </a:defRPr>
+            </a:pPr>
+            <a:r>
+              <a:t>A Smart Web Platform to Track, Predict, and Protect the Mental Health of Soldiers</a:t>
+            </a:r>
+          </a:p>
+        </p:txBody>
+      </p:sp>
+      <p:sp>
+        <p:nvSpPr>
+          <p:cNvPr id="6" name="Rounded Rectangle 5"/>
+          <p:cNvSpPr/>
+          <p:nvPr/>
+        </p:nvSpPr>
+        <p:spPr>
+          <a:xfrm>
+            <a:off x="914400" y="3017520"/>
+            <a:ext cx="10362895" cy="2834640"/>
+          </a:xfrm>
+          <a:prstGeom prst="roundRect">
+            <a:avLst/>
+          </a:prstGeom>
+          <a:solidFill>
+            <a:srgbClr val="F8FAFC"/>
+          </a:solidFill>
+          <a:ln w="19050">
+            <a:solidFill>
+              <a:srgbClr val="94A3B8"/>
+            </a:solidFill>
+          </a:ln>
+        </p:spPr>
+        <p:style>
+          <a:lnRef idx="1">
+            <a:schemeClr val="accent1"/>
+          </a:lnRef>
+          <a:fillRef idx="3">
+            <a:schemeClr val="accent1"/>
+          </a:fillRef>
+          <a:effectRef idx="2">
+            <a:schemeClr val="accent1"/>
+          </a:effectRef>
+          <a:fontRef idx="minor">
+            <a:schemeClr val="lt1"/>
+          </a:fontRef>
+        </p:style>
+        <p:txBody>
           <a:bodyPr rtlCol="0" anchor="t" wrap="square"/>
           <a:lstStyle/>
           <a:p>
             <a:pPr algn="ctr">
               <a:spcAft>
-                <a:spcPts val="1400"/>
+                <a:spcPts val="1200"/>
               </a:spcAft>
               <a:defRPr sz="1200" b="1">
                 <a:solidFill>
-                  <a:srgbClr val="38BDF8"/>
-                </a:solidFill>
-                <a:latin typeface="Calibri"/>
-              </a:defRPr>
-            </a:pPr>
-            <a:r>
-              <a:t>CANDIDATE &amp; ACADEMIC CREDENTIALS</a:t>
+                  <a:srgbClr val="1D4ED8"/>
+                </a:solidFill>
+                <a:latin typeface="Arial"/>
+              </a:defRPr>
+            </a:pPr>
+            <a:r>
+              <a:t>STUDENT &amp; PROJECT DETAILS</a:t>
             </a:r>
           </a:p>
           <a:p>
@@ -3308,9 +3353,9 @@
               <a:spcAft>
                 <a:spcPts val="600"/>
               </a:spcAft>
-              <a:defRPr sz="1300" b="1">
-                <a:solidFill>
-                  <a:srgbClr val="FFFFFF"/>
+              <a:defRPr sz="1250" b="1">
+                <a:solidFill>
+                  <a:srgbClr val="0F172A"/>
                 </a:solidFill>
                 <a:latin typeface="Consolas"/>
               </a:defRPr>
@@ -3324,9 +3369,9 @@
               <a:spcAft>
                 <a:spcPts val="600"/>
               </a:spcAft>
-              <a:defRPr sz="1300" b="1">
-                <a:solidFill>
-                  <a:srgbClr val="FFFFFF"/>
+              <a:defRPr sz="1250" b="1">
+                <a:solidFill>
+                  <a:srgbClr val="0F172A"/>
                 </a:solidFill>
                 <a:latin typeface="Consolas"/>
               </a:defRPr>
@@ -3340,9 +3385,9 @@
               <a:spcAft>
                 <a:spcPts val="600"/>
               </a:spcAft>
-              <a:defRPr sz="1300" b="1">
-                <a:solidFill>
-                  <a:srgbClr val="FFFFFF"/>
+              <a:defRPr sz="1250" b="1">
+                <a:solidFill>
+                  <a:srgbClr val="0F172A"/>
                 </a:solidFill>
                 <a:latin typeface="Consolas"/>
               </a:defRPr>
@@ -3356,9 +3401,9 @@
               <a:spcAft>
                 <a:spcPts val="600"/>
               </a:spcAft>
-              <a:defRPr sz="1300" b="1">
-                <a:solidFill>
-                  <a:srgbClr val="FFFFFF"/>
+              <a:defRPr sz="1250" b="1">
+                <a:solidFill>
+                  <a:srgbClr val="0F172A"/>
                 </a:solidFill>
                 <a:latin typeface="Consolas"/>
               </a:defRPr>
@@ -3402,7 +3447,7 @@
             <a:avLst/>
           </a:prstGeom>
           <a:solidFill>
-            <a:srgbClr val="F8FAFC"/>
+            <a:srgbClr val="FFFFFF"/>
           </a:solidFill>
           <a:ln>
             <a:noFill/>
@@ -3438,18 +3483,18 @@
         </p:nvSpPr>
         <p:spPr>
           <a:xfrm>
-            <a:off x="822960" y="457200"/>
-            <a:ext cx="2926080" cy="320040"/>
+            <a:off x="822960" y="411480"/>
+            <a:ext cx="3200400" cy="320040"/>
           </a:xfrm>
           <a:prstGeom prst="roundRect">
             <a:avLst/>
           </a:prstGeom>
           <a:solidFill>
-            <a:srgbClr val="EFF6FF"/>
+            <a:srgbClr val="F1F5F9"/>
           </a:solidFill>
           <a:ln>
             <a:solidFill>
-              <a:srgbClr val="BFDBFE"/>
+              <a:srgbClr val="94A3B8"/>
             </a:solidFill>
           </a:ln>
         </p:spPr>
@@ -3474,13 +3519,13 @@
             <a:pPr algn="ctr">
               <a:defRPr sz="950" b="1">
                 <a:solidFill>
-                  <a:srgbClr val="2563EB"/>
-                </a:solidFill>
-                <a:latin typeface="Calibri"/>
-              </a:defRPr>
-            </a:pPr>
-            <a:r>
-              <a:t>SLIDE 10 | CONCLUSION</a:t>
+                  <a:srgbClr val="1D4ED8"/>
+                </a:solidFill>
+                <a:latin typeface="Arial"/>
+              </a:defRPr>
+            </a:pPr>
+            <a:r>
+              <a:t>SLIDE 10 | CONCLUSION &amp; FUTURE SCOPE</a:t>
             </a:r>
           </a:p>
         </p:txBody>
@@ -3493,7 +3538,7 @@
         </p:nvSpPr>
         <p:spPr>
           <a:xfrm>
-            <a:off x="822960" y="822960"/>
+            <a:off x="822960" y="777240"/>
             <a:ext cx="10515600" cy="731520"/>
           </a:xfrm>
           <a:prstGeom prst="rect">
@@ -3508,15 +3553,15 @@
           <a:lstStyle/>
           <a:p>
             <a:pPr>
-              <a:defRPr sz="2200" b="1">
+              <a:defRPr sz="2100" b="1">
                 <a:solidFill>
                   <a:srgbClr val="0F172A"/>
                 </a:solidFill>
-                <a:latin typeface="Calibri"/>
-              </a:defRPr>
-            </a:pPr>
-            <a:r>
-              <a:t>Project Summary &amp; Future Research Directions</a:t>
+                <a:latin typeface="Arial"/>
+              </a:defRPr>
+            </a:pPr>
+            <a:r>
+              <a:t>Project Summary &amp; Next Steps</a:t>
             </a:r>
           </a:p>
         </p:txBody>
@@ -3529,8 +3574,8 @@
         </p:nvSpPr>
         <p:spPr>
           <a:xfrm>
-            <a:off x="822960" y="1691640"/>
-            <a:ext cx="10545775" cy="1417320"/>
+            <a:off x="822960" y="1600200"/>
+            <a:ext cx="10545775" cy="1463040"/>
           </a:xfrm>
           <a:prstGeom prst="roundRect">
             <a:avLst/>
@@ -3540,7 +3585,7 @@
           </a:solidFill>
           <a:ln w="12700">
             <a:solidFill>
-              <a:srgbClr val="CBD5E1"/>
+              <a:srgbClr val="94A3B8"/>
             </a:solidFill>
           </a:ln>
         </p:spPr>
@@ -3574,17 +3619,19 @@
         </p:nvSpPr>
         <p:spPr>
           <a:xfrm>
-            <a:off x="1051560" y="1920240"/>
-            <a:ext cx="822960" cy="868680"/>
+            <a:off x="1051560" y="1856232"/>
+            <a:ext cx="777240" cy="868680"/>
           </a:xfrm>
           <a:prstGeom prst="roundRect">
             <a:avLst/>
           </a:prstGeom>
           <a:solidFill>
-            <a:srgbClr val="2563EB"/>
-          </a:solidFill>
-          <a:ln>
-            <a:noFill/>
+            <a:srgbClr val="F1F5F9"/>
+          </a:solidFill>
+          <a:ln w="19050">
+            <a:solidFill>
+              <a:srgbClr val="1D4ED8"/>
+            </a:solidFill>
           </a:ln>
         </p:spPr>
         <p:style>
@@ -3608,9 +3655,9 @@
             <a:pPr algn="ctr">
               <a:defRPr sz="2000" b="1">
                 <a:solidFill>
-                  <a:srgbClr val="FFFFFF"/>
-                </a:solidFill>
-                <a:latin typeface="Calibri"/>
+                  <a:srgbClr val="1D4ED8"/>
+                </a:solidFill>
+                <a:latin typeface="Arial"/>
               </a:defRPr>
             </a:pPr>
             <a:r>
@@ -3627,8 +3674,8 @@
         </p:nvSpPr>
         <p:spPr>
           <a:xfrm>
-            <a:off x="2057400" y="1828800"/>
-            <a:ext cx="9144000" cy="1143000"/>
+            <a:off x="2057400" y="1737360"/>
+            <a:ext cx="9144000" cy="1188720"/>
           </a:xfrm>
           <a:prstGeom prst="rect">
             <a:avLst/>
@@ -3642,15 +3689,15 @@
           <a:lstStyle/>
           <a:p>
             <a:pPr>
-              <a:defRPr sz="1400" b="1">
+              <a:defRPr sz="1350" b="1">
                 <a:solidFill>
                   <a:srgbClr val="0F172A"/>
                 </a:solidFill>
-                <a:latin typeface="Calibri"/>
-              </a:defRPr>
-            </a:pPr>
-            <a:r>
-              <a:t>Production-Ready Deployment &amp; Real-World Impact</a:t>
+                <a:latin typeface="Arial"/>
+              </a:defRPr>
+            </a:pPr>
+            <a:r>
+              <a:t>Successfully Tested &amp; Live Online</a:t>
             </a:r>
           </a:p>
           <a:p>
@@ -3658,15 +3705,15 @@
               <a:spcBef>
                 <a:spcPts val="400"/>
               </a:spcBef>
-              <a:defRPr sz="1150">
-                <a:solidFill>
-                  <a:srgbClr val="334155"/>
-                </a:solidFill>
-                <a:latin typeface="Calibri"/>
-              </a:defRPr>
-            </a:pPr>
-            <a:r>
-              <a:t>Successfully tested and deployed live on Vercel (https://apps-nu-henna.vercel.app), delivering a zero-latency digital welfare shield for defense forces.</a:t>
+              <a:defRPr sz="1100">
+                <a:solidFill>
+                  <a:srgbClr val="1E293B"/>
+                </a:solidFill>
+                <a:latin typeface="Arial"/>
+              </a:defRPr>
+            </a:pPr>
+            <a:r>
+              <a:t>The project is 100% completed and deployed live on Vercel at https://apps-nu-henna.vercel.app for real-world testing.</a:t>
             </a:r>
           </a:p>
         </p:txBody>
@@ -3679,8 +3726,8 @@
         </p:nvSpPr>
         <p:spPr>
           <a:xfrm>
-            <a:off x="822960" y="3291840"/>
-            <a:ext cx="10545775" cy="1417320"/>
+            <a:off x="822960" y="3246120"/>
+            <a:ext cx="10545775" cy="1463040"/>
           </a:xfrm>
           <a:prstGeom prst="roundRect">
             <a:avLst/>
@@ -3690,7 +3737,7 @@
           </a:solidFill>
           <a:ln w="12700">
             <a:solidFill>
-              <a:srgbClr val="CBD5E1"/>
+              <a:srgbClr val="94A3B8"/>
             </a:solidFill>
           </a:ln>
         </p:spPr>
@@ -3724,17 +3771,19 @@
         </p:nvSpPr>
         <p:spPr>
           <a:xfrm>
-            <a:off x="1051560" y="3520440"/>
-            <a:ext cx="822960" cy="868680"/>
+            <a:off x="1051560" y="3502152"/>
+            <a:ext cx="777240" cy="868680"/>
           </a:xfrm>
           <a:prstGeom prst="roundRect">
             <a:avLst/>
           </a:prstGeom>
           <a:solidFill>
-            <a:srgbClr val="0D9488"/>
-          </a:solidFill>
-          <a:ln>
-            <a:noFill/>
+            <a:srgbClr val="F1F5F9"/>
+          </a:solidFill>
+          <a:ln w="19050">
+            <a:solidFill>
+              <a:srgbClr val="0F766E"/>
+            </a:solidFill>
           </a:ln>
         </p:spPr>
         <p:style>
@@ -3758,9 +3807,9 @@
             <a:pPr algn="ctr">
               <a:defRPr sz="2000" b="1">
                 <a:solidFill>
-                  <a:srgbClr val="FFFFFF"/>
-                </a:solidFill>
-                <a:latin typeface="Calibri"/>
+                  <a:srgbClr val="0F766E"/>
+                </a:solidFill>
+                <a:latin typeface="Arial"/>
               </a:defRPr>
             </a:pPr>
             <a:r>
@@ -3777,8 +3826,8 @@
         </p:nvSpPr>
         <p:spPr>
           <a:xfrm>
-            <a:off x="2057400" y="3429000"/>
-            <a:ext cx="9144000" cy="1143000"/>
+            <a:off x="2057400" y="3383280"/>
+            <a:ext cx="9144000" cy="1188720"/>
           </a:xfrm>
           <a:prstGeom prst="rect">
             <a:avLst/>
@@ -3792,15 +3841,15 @@
           <a:lstStyle/>
           <a:p>
             <a:pPr>
-              <a:defRPr sz="1400" b="1">
+              <a:defRPr sz="1350" b="1">
                 <a:solidFill>
                   <a:srgbClr val="0F172A"/>
                 </a:solidFill>
-                <a:latin typeface="Calibri"/>
-              </a:defRPr>
-            </a:pPr>
-            <a:r>
-              <a:t>Friction-Free Direct Access &amp; Complete Transparency</a:t>
+                <a:latin typeface="Arial"/>
+              </a:defRPr>
+            </a:pPr>
+            <a:r>
+              <a:t>Fast, Friction-Free Experience</a:t>
             </a:r>
           </a:p>
           <a:p>
@@ -3808,15 +3857,15 @@
               <a:spcBef>
                 <a:spcPts val="400"/>
               </a:spcBef>
-              <a:defRPr sz="1150">
-                <a:solidFill>
-                  <a:srgbClr val="334155"/>
-                </a:solidFill>
-                <a:latin typeface="Calibri"/>
-              </a:defRPr>
-            </a:pPr>
-            <a:r>
-              <a:t>Eliminated unnecessary authentication barriers for fast soldier reporting while maintaining strict command PIN gating and multi-role audit logging.</a:t>
+              <a:defRPr sz="1100">
+                <a:solidFill>
+                  <a:srgbClr val="1E293B"/>
+                </a:solidFill>
+                <a:latin typeface="Arial"/>
+              </a:defRPr>
+            </a:pPr>
+            <a:r>
+              <a:t>Removed all slow verification barriers so soldiers can log in directly and submit their health records in under 30 seconds.</a:t>
             </a:r>
           </a:p>
         </p:txBody>
@@ -3830,7 +3879,7 @@
         <p:spPr>
           <a:xfrm>
             <a:off x="822960" y="4892040"/>
-            <a:ext cx="10545775" cy="1417320"/>
+            <a:ext cx="10545775" cy="1463040"/>
           </a:xfrm>
           <a:prstGeom prst="roundRect">
             <a:avLst/>
@@ -3840,7 +3889,7 @@
           </a:solidFill>
           <a:ln w="12700">
             <a:solidFill>
-              <a:srgbClr val="CBD5E1"/>
+              <a:srgbClr val="94A3B8"/>
             </a:solidFill>
           </a:ln>
         </p:spPr>
@@ -3874,17 +3923,19 @@
         </p:nvSpPr>
         <p:spPr>
           <a:xfrm>
-            <a:off x="1051560" y="5120640"/>
-            <a:ext cx="822960" cy="868680"/>
+            <a:off x="1051560" y="5148072"/>
+            <a:ext cx="777240" cy="868680"/>
           </a:xfrm>
           <a:prstGeom prst="roundRect">
             <a:avLst/>
           </a:prstGeom>
           <a:solidFill>
-            <a:srgbClr val="0F172A"/>
-          </a:solidFill>
-          <a:ln>
-            <a:noFill/>
+            <a:srgbClr val="F1F5F9"/>
+          </a:solidFill>
+          <a:ln w="19050">
+            <a:solidFill>
+              <a:srgbClr val="0F172A"/>
+            </a:solidFill>
           </a:ln>
         </p:spPr>
         <p:style>
@@ -3908,9 +3959,9 @@
             <a:pPr algn="ctr">
               <a:defRPr sz="2000" b="1">
                 <a:solidFill>
-                  <a:srgbClr val="FFFFFF"/>
-                </a:solidFill>
-                <a:latin typeface="Calibri"/>
+                  <a:srgbClr val="0F172A"/>
+                </a:solidFill>
+                <a:latin typeface="Arial"/>
               </a:defRPr>
             </a:pPr>
             <a:r>
@@ -3928,7 +3979,7 @@
         <p:spPr>
           <a:xfrm>
             <a:off x="2057400" y="5029200"/>
-            <a:ext cx="9144000" cy="1143000"/>
+            <a:ext cx="9144000" cy="1188720"/>
           </a:xfrm>
           <a:prstGeom prst="rect">
             <a:avLst/>
@@ -3942,15 +3993,15 @@
           <a:lstStyle/>
           <a:p>
             <a:pPr>
-              <a:defRPr sz="1400" b="1">
+              <a:defRPr sz="1350" b="1">
                 <a:solidFill>
                   <a:srgbClr val="0F172A"/>
                 </a:solidFill>
-                <a:latin typeface="Calibri"/>
-              </a:defRPr>
-            </a:pPr>
-            <a:r>
-              <a:t>Future Roadmap: Wearable IoT &amp; Voice Sentiment AI</a:t>
+                <a:latin typeface="Arial"/>
+              </a:defRPr>
+            </a:pPr>
+            <a:r>
+              <a:t>Future Plans: Real Smartwatches &amp; Voice AI</a:t>
             </a:r>
           </a:p>
           <a:p>
@@ -3958,15 +4009,15 @@
               <a:spcBef>
                 <a:spcPts val="400"/>
               </a:spcBef>
-              <a:defRPr sz="1150">
-                <a:solidFill>
-                  <a:srgbClr val="334155"/>
-                </a:solidFill>
-                <a:latin typeface="Calibri"/>
-              </a:defRPr>
-            </a:pPr>
-            <a:r>
-              <a:t>Planned extensions include direct Bluetooth smartwatch hardware pairing, AI voice sentiment analysis during counseling, and edge-mesh offline database sync.</a:t>
+              <a:defRPr sz="1100">
+                <a:solidFill>
+                  <a:srgbClr val="1E293B"/>
+                </a:solidFill>
+                <a:latin typeface="Arial"/>
+              </a:defRPr>
+            </a:pPr>
+            <a:r>
+              <a:t>Future upgrades include direct Bluetooth pairing with actual military smartwatches and AI voice sentiment analysis during counseling.</a:t>
             </a:r>
           </a:p>
         </p:txBody>
@@ -3979,7 +4030,7 @@
         </p:nvSpPr>
         <p:spPr>
           <a:xfrm>
-            <a:off x="822960" y="6400800"/>
+            <a:off x="822960" y="6446520"/>
             <a:ext cx="10515600" cy="320040"/>
           </a:xfrm>
           <a:prstGeom prst="rect">
@@ -3998,11 +4049,11 @@
                 <a:solidFill>
                   <a:srgbClr val="64748B"/>
                 </a:solidFill>
-                <a:latin typeface="Calibri"/>
-              </a:defRPr>
-            </a:pPr>
-            <a:r>
-              <a:t>APPS - AI Predictive Personnel Stress &amp; Welfare Monitoring Systems | Computer Science &amp; Business Systems</a:t>
+                <a:latin typeface="Arial"/>
+              </a:defRPr>
+            </a:pPr>
+            <a:r>
+              <a:t>APPS - Final Year Mini Project | DHARUN.M (CSBS) | Slide 10 of 10</a:t>
             </a:r>
           </a:p>
         </p:txBody>
@@ -4040,7 +4091,7 @@
             <a:avLst/>
           </a:prstGeom>
           <a:solidFill>
-            <a:srgbClr val="F8FAFC"/>
+            <a:srgbClr val="FFFFFF"/>
           </a:solidFill>
           <a:ln>
             <a:noFill/>
@@ -4076,18 +4127,18 @@
         </p:nvSpPr>
         <p:spPr>
           <a:xfrm>
-            <a:off x="822960" y="457200"/>
-            <a:ext cx="2926080" cy="320040"/>
+            <a:off x="822960" y="411480"/>
+            <a:ext cx="3200400" cy="320040"/>
           </a:xfrm>
           <a:prstGeom prst="roundRect">
             <a:avLst/>
           </a:prstGeom>
           <a:solidFill>
-            <a:srgbClr val="EFF6FF"/>
+            <a:srgbClr val="F1F5F9"/>
           </a:solidFill>
           <a:ln>
             <a:solidFill>
-              <a:srgbClr val="BFDBFE"/>
+              <a:srgbClr val="94A3B8"/>
             </a:solidFill>
           </a:ln>
         </p:spPr>
@@ -4112,9 +4163,9 @@
             <a:pPr algn="ctr">
               <a:defRPr sz="950" b="1">
                 <a:solidFill>
-                  <a:srgbClr val="2563EB"/>
-                </a:solidFill>
-                <a:latin typeface="Calibri"/>
+                  <a:srgbClr val="1D4ED8"/>
+                </a:solidFill>
+                <a:latin typeface="Arial"/>
               </a:defRPr>
             </a:pPr>
             <a:r>
@@ -4131,7 +4182,7 @@
         </p:nvSpPr>
         <p:spPr>
           <a:xfrm>
-            <a:off x="822960" y="822960"/>
+            <a:off x="822960" y="777240"/>
             <a:ext cx="10515600" cy="731520"/>
           </a:xfrm>
           <a:prstGeom prst="rect">
@@ -4146,15 +4197,15 @@
           <a:lstStyle/>
           <a:p>
             <a:pPr>
-              <a:defRPr sz="2200" b="1">
+              <a:defRPr sz="2100" b="1">
                 <a:solidFill>
                   <a:srgbClr val="0F172A"/>
                 </a:solidFill>
-                <a:latin typeface="Calibri"/>
-              </a:defRPr>
-            </a:pPr>
-            <a:r>
-              <a:t>Challenges in Armed Forces Psychological Welfare</a:t>
+                <a:latin typeface="Arial"/>
+              </a:defRPr>
+            </a:pPr>
+            <a:r>
+              <a:t>Why is This Project Needed? (Real Military Challenges)</a:t>
             </a:r>
           </a:p>
         </p:txBody>
@@ -4167,8 +4218,8 @@
         </p:nvSpPr>
         <p:spPr>
           <a:xfrm>
-            <a:off x="822960" y="1691640"/>
-            <a:ext cx="10545775" cy="1417320"/>
+            <a:off x="822960" y="1600200"/>
+            <a:ext cx="10545775" cy="1463040"/>
           </a:xfrm>
           <a:prstGeom prst="roundRect">
             <a:avLst/>
@@ -4178,7 +4229,7 @@
           </a:solidFill>
           <a:ln w="12700">
             <a:solidFill>
-              <a:srgbClr val="CBD5E1"/>
+              <a:srgbClr val="94A3B8"/>
             </a:solidFill>
           </a:ln>
         </p:spPr>
@@ -4212,17 +4263,19 @@
         </p:nvSpPr>
         <p:spPr>
           <a:xfrm>
-            <a:off x="1051560" y="1920240"/>
-            <a:ext cx="822960" cy="868680"/>
+            <a:off x="1051560" y="1856232"/>
+            <a:ext cx="777240" cy="868680"/>
           </a:xfrm>
           <a:prstGeom prst="roundRect">
             <a:avLst/>
           </a:prstGeom>
           <a:solidFill>
-            <a:srgbClr val="2563EB"/>
-          </a:solidFill>
-          <a:ln>
-            <a:noFill/>
+            <a:srgbClr val="F1F5F9"/>
+          </a:solidFill>
+          <a:ln w="19050">
+            <a:solidFill>
+              <a:srgbClr val="1D4ED8"/>
+            </a:solidFill>
           </a:ln>
         </p:spPr>
         <p:style>
@@ -4246,9 +4299,9 @@
             <a:pPr algn="ctr">
               <a:defRPr sz="2000" b="1">
                 <a:solidFill>
-                  <a:srgbClr val="FFFFFF"/>
-                </a:solidFill>
-                <a:latin typeface="Calibri"/>
+                  <a:srgbClr val="1D4ED8"/>
+                </a:solidFill>
+                <a:latin typeface="Arial"/>
               </a:defRPr>
             </a:pPr>
             <a:r>
@@ -4265,8 +4318,8 @@
         </p:nvSpPr>
         <p:spPr>
           <a:xfrm>
-            <a:off x="2057400" y="1828800"/>
-            <a:ext cx="9144000" cy="1143000"/>
+            <a:off x="2057400" y="1737360"/>
+            <a:ext cx="9144000" cy="1188720"/>
           </a:xfrm>
           <a:prstGeom prst="rect">
             <a:avLst/>
@@ -4280,15 +4333,15 @@
           <a:lstStyle/>
           <a:p>
             <a:pPr>
-              <a:defRPr sz="1400" b="1">
+              <a:defRPr sz="1350" b="1">
                 <a:solidFill>
                   <a:srgbClr val="0F172A"/>
                 </a:solidFill>
-                <a:latin typeface="Calibri"/>
-              </a:defRPr>
-            </a:pPr>
-            <a:r>
-              <a:t>Undetected Combat Fatigue &amp; Operational Strain</a:t>
+                <a:latin typeface="Arial"/>
+              </a:defRPr>
+            </a:pPr>
+            <a:r>
+              <a:t>Hidden Stress in Field Duty</a:t>
             </a:r>
           </a:p>
           <a:p>
@@ -4296,15 +4349,15 @@
               <a:spcBef>
                 <a:spcPts val="400"/>
               </a:spcBef>
-              <a:defRPr sz="1150">
-                <a:solidFill>
-                  <a:srgbClr val="334155"/>
-                </a:solidFill>
-                <a:latin typeface="Calibri"/>
-              </a:defRPr>
-            </a:pPr>
-            <a:r>
-              <a:t>Armed forces personnel face prolonged high-intensity combat exposure and erratic sleep schedules, leading to cumulative mental exhaustion that frequently goes unnoticed.</a:t>
+              <a:defRPr sz="1100">
+                <a:solidFill>
+                  <a:srgbClr val="1E293B"/>
+                </a:solidFill>
+                <a:latin typeface="Arial"/>
+              </a:defRPr>
+            </a:pPr>
+            <a:r>
+              <a:t>Soldiers deployed in remote border areas face high mental pressure and very little sleep, but their daily stress goes unnoticed until it becomes severe.</a:t>
             </a:r>
           </a:p>
         </p:txBody>
@@ -4317,8 +4370,8 @@
         </p:nvSpPr>
         <p:spPr>
           <a:xfrm>
-            <a:off x="822960" y="3291840"/>
-            <a:ext cx="10545775" cy="1417320"/>
+            <a:off x="822960" y="3246120"/>
+            <a:ext cx="10545775" cy="1463040"/>
           </a:xfrm>
           <a:prstGeom prst="roundRect">
             <a:avLst/>
@@ -4328,7 +4381,7 @@
           </a:solidFill>
           <a:ln w="12700">
             <a:solidFill>
-              <a:srgbClr val="CBD5E1"/>
+              <a:srgbClr val="94A3B8"/>
             </a:solidFill>
           </a:ln>
         </p:spPr>
@@ -4362,17 +4415,19 @@
         </p:nvSpPr>
         <p:spPr>
           <a:xfrm>
-            <a:off x="1051560" y="3520440"/>
-            <a:ext cx="822960" cy="868680"/>
+            <a:off x="1051560" y="3502152"/>
+            <a:ext cx="777240" cy="868680"/>
           </a:xfrm>
           <a:prstGeom prst="roundRect">
             <a:avLst/>
           </a:prstGeom>
           <a:solidFill>
-            <a:srgbClr val="0D9488"/>
-          </a:solidFill>
-          <a:ln>
-            <a:noFill/>
+            <a:srgbClr val="F1F5F9"/>
+          </a:solidFill>
+          <a:ln w="19050">
+            <a:solidFill>
+              <a:srgbClr val="0F766E"/>
+            </a:solidFill>
           </a:ln>
         </p:spPr>
         <p:style>
@@ -4396,9 +4451,9 @@
             <a:pPr algn="ctr">
               <a:defRPr sz="2000" b="1">
                 <a:solidFill>
-                  <a:srgbClr val="FFFFFF"/>
-                </a:solidFill>
-                <a:latin typeface="Calibri"/>
+                  <a:srgbClr val="0F766E"/>
+                </a:solidFill>
+                <a:latin typeface="Arial"/>
               </a:defRPr>
             </a:pPr>
             <a:r>
@@ -4415,8 +4470,8 @@
         </p:nvSpPr>
         <p:spPr>
           <a:xfrm>
-            <a:off x="2057400" y="3429000"/>
-            <a:ext cx="9144000" cy="1143000"/>
+            <a:off x="2057400" y="3383280"/>
+            <a:ext cx="9144000" cy="1188720"/>
           </a:xfrm>
           <a:prstGeom prst="rect">
             <a:avLst/>
@@ -4430,15 +4485,15 @@
           <a:lstStyle/>
           <a:p>
             <a:pPr>
-              <a:defRPr sz="1400" b="1">
+              <a:defRPr sz="1350" b="1">
                 <a:solidFill>
                   <a:srgbClr val="0F172A"/>
                 </a:solidFill>
-                <a:latin typeface="Calibri"/>
-              </a:defRPr>
-            </a:pPr>
-            <a:r>
-              <a:t>Infrequent Manual Evaluations &amp; Fatal Delays</a:t>
+                <a:latin typeface="Arial"/>
+              </a:defRPr>
+            </a:pPr>
+            <a:r>
+              <a:t>Manual Check-ups are Too Late</a:t>
             </a:r>
           </a:p>
           <a:p>
@@ -4446,15 +4501,15 @@
               <a:spcBef>
                 <a:spcPts val="400"/>
               </a:spcBef>
-              <a:defRPr sz="1150">
-                <a:solidFill>
-                  <a:srgbClr val="334155"/>
-                </a:solidFill>
-                <a:latin typeface="Calibri"/>
-              </a:defRPr>
-            </a:pPr>
-            <a:r>
-              <a:t>Traditional military welfare relies on sporadic, in-person psychological reviews that create critical response delays in suicide prevention and mental trauma intervention.</a:t>
+              <a:defRPr sz="1100">
+                <a:solidFill>
+                  <a:srgbClr val="1E293B"/>
+                </a:solidFill>
+                <a:latin typeface="Arial"/>
+              </a:defRPr>
+            </a:pPr>
+            <a:r>
+              <a:t>Existing psychological reviews happen only once in 3 or 6 months. This huge delay prevents officers from stopping critical mental breakdowns in time.</a:t>
             </a:r>
           </a:p>
         </p:txBody>
@@ -4468,7 +4523,7 @@
         <p:spPr>
           <a:xfrm>
             <a:off x="822960" y="4892040"/>
-            <a:ext cx="10545775" cy="1417320"/>
+            <a:ext cx="10545775" cy="1463040"/>
           </a:xfrm>
           <a:prstGeom prst="roundRect">
             <a:avLst/>
@@ -4478,7 +4533,7 @@
           </a:solidFill>
           <a:ln w="12700">
             <a:solidFill>
-              <a:srgbClr val="CBD5E1"/>
+              <a:srgbClr val="94A3B8"/>
             </a:solidFill>
           </a:ln>
         </p:spPr>
@@ -4512,17 +4567,19 @@
         </p:nvSpPr>
         <p:spPr>
           <a:xfrm>
-            <a:off x="1051560" y="5120640"/>
-            <a:ext cx="822960" cy="868680"/>
+            <a:off x="1051560" y="5148072"/>
+            <a:ext cx="777240" cy="868680"/>
           </a:xfrm>
           <a:prstGeom prst="roundRect">
             <a:avLst/>
           </a:prstGeom>
           <a:solidFill>
-            <a:srgbClr val="0F172A"/>
-          </a:solidFill>
-          <a:ln>
-            <a:noFill/>
+            <a:srgbClr val="F1F5F9"/>
+          </a:solidFill>
+          <a:ln w="19050">
+            <a:solidFill>
+              <a:srgbClr val="0F172A"/>
+            </a:solidFill>
           </a:ln>
         </p:spPr>
         <p:style>
@@ -4546,9 +4603,9 @@
             <a:pPr algn="ctr">
               <a:defRPr sz="2000" b="1">
                 <a:solidFill>
-                  <a:srgbClr val="FFFFFF"/>
-                </a:solidFill>
-                <a:latin typeface="Calibri"/>
+                  <a:srgbClr val="0F172A"/>
+                </a:solidFill>
+                <a:latin typeface="Arial"/>
               </a:defRPr>
             </a:pPr>
             <a:r>
@@ -4566,7 +4623,7 @@
         <p:spPr>
           <a:xfrm>
             <a:off x="2057400" y="5029200"/>
-            <a:ext cx="9144000" cy="1143000"/>
+            <a:ext cx="9144000" cy="1188720"/>
           </a:xfrm>
           <a:prstGeom prst="rect">
             <a:avLst/>
@@ -4580,15 +4637,15 @@
           <a:lstStyle/>
           <a:p>
             <a:pPr>
-              <a:defRPr sz="1400" b="1">
+              <a:defRPr sz="1350" b="1">
                 <a:solidFill>
                   <a:srgbClr val="0F172A"/>
                 </a:solidFill>
-                <a:latin typeface="Calibri"/>
-              </a:defRPr>
-            </a:pPr>
-            <a:r>
-              <a:t>Absence of Confidential Real-Time Triage Systems</a:t>
+                <a:latin typeface="Arial"/>
+              </a:defRPr>
+            </a:pPr>
+            <a:r>
+              <a:t>Soldiers Hesitate to Share Directly</a:t>
             </a:r>
           </a:p>
           <a:p>
@@ -4596,15 +4653,15 @@
               <a:spcBef>
                 <a:spcPts val="400"/>
               </a:spcBef>
-              <a:defRPr sz="1150">
-                <a:solidFill>
-                  <a:srgbClr val="334155"/>
-                </a:solidFill>
-                <a:latin typeface="Calibri"/>
-              </a:defRPr>
-            </a:pPr>
-            <a:r>
-              <a:t>Soldiers often hesitate to report mental health struggles due to social stigma, while commanding officers lack automated tools to detect high-risk personnel early.</a:t>
+              <a:defRPr sz="1100">
+                <a:solidFill>
+                  <a:srgbClr val="1E293B"/>
+                </a:solidFill>
+                <a:latin typeface="Arial"/>
+              </a:defRPr>
+            </a:pPr>
+            <a:r>
+              <a:t>Due to fear and hesitation, soldiers do not talk about their sadness openly, and commanding officers have no digital tool to spot high-risk jawans early.</a:t>
             </a:r>
           </a:p>
         </p:txBody>
@@ -4617,7 +4674,7 @@
         </p:nvSpPr>
         <p:spPr>
           <a:xfrm>
-            <a:off x="822960" y="6400800"/>
+            <a:off x="822960" y="6446520"/>
             <a:ext cx="10515600" cy="320040"/>
           </a:xfrm>
           <a:prstGeom prst="rect">
@@ -4636,11 +4693,11 @@
                 <a:solidFill>
                   <a:srgbClr val="64748B"/>
                 </a:solidFill>
-                <a:latin typeface="Calibri"/>
-              </a:defRPr>
-            </a:pPr>
-            <a:r>
-              <a:t>APPS - AI Predictive Personnel Stress &amp; Welfare Monitoring Systems | Computer Science &amp; Business Systems</a:t>
+                <a:latin typeface="Arial"/>
+              </a:defRPr>
+            </a:pPr>
+            <a:r>
+              <a:t>APPS - Final Year Mini Project | DHARUN.M (CSBS) | Slide 2 of 10</a:t>
             </a:r>
           </a:p>
         </p:txBody>
@@ -4678,7 +4735,7 @@
             <a:avLst/>
           </a:prstGeom>
           <a:solidFill>
-            <a:srgbClr val="F8FAFC"/>
+            <a:srgbClr val="FFFFFF"/>
           </a:solidFill>
           <a:ln>
             <a:noFill/>
@@ -4714,18 +4771,18 @@
         </p:nvSpPr>
         <p:spPr>
           <a:xfrm>
-            <a:off x="822960" y="457200"/>
-            <a:ext cx="2926080" cy="320040"/>
+            <a:off x="822960" y="411480"/>
+            <a:ext cx="3200400" cy="320040"/>
           </a:xfrm>
           <a:prstGeom prst="roundRect">
             <a:avLst/>
           </a:prstGeom>
           <a:solidFill>
-            <a:srgbClr val="EFF6FF"/>
+            <a:srgbClr val="F1F5F9"/>
           </a:solidFill>
           <a:ln>
             <a:solidFill>
-              <a:srgbClr val="BFDBFE"/>
+              <a:srgbClr val="94A3B8"/>
             </a:solidFill>
           </a:ln>
         </p:spPr>
@@ -4750,13 +4807,13 @@
             <a:pPr algn="ctr">
               <a:defRPr sz="950" b="1">
                 <a:solidFill>
-                  <a:srgbClr val="2563EB"/>
-                </a:solidFill>
-                <a:latin typeface="Calibri"/>
-              </a:defRPr>
-            </a:pPr>
-            <a:r>
-              <a:t>SLIDE 03 | OBJECTIVES</a:t>
+                  <a:srgbClr val="1D4ED8"/>
+                </a:solidFill>
+                <a:latin typeface="Arial"/>
+              </a:defRPr>
+            </a:pPr>
+            <a:r>
+              <a:t>SLIDE 03 | PROJECT OBJECTIVES</a:t>
             </a:r>
           </a:p>
         </p:txBody>
@@ -4769,7 +4826,7 @@
         </p:nvSpPr>
         <p:spPr>
           <a:xfrm>
-            <a:off x="822960" y="822960"/>
+            <a:off x="822960" y="777240"/>
             <a:ext cx="10515600" cy="731520"/>
           </a:xfrm>
           <a:prstGeom prst="rect">
@@ -4784,15 +4841,15 @@
           <a:lstStyle/>
           <a:p>
             <a:pPr>
-              <a:defRPr sz="2200" b="1">
+              <a:defRPr sz="2100" b="1">
                 <a:solidFill>
                   <a:srgbClr val="0F172A"/>
                 </a:solidFill>
-                <a:latin typeface="Calibri"/>
-              </a:defRPr>
-            </a:pPr>
-            <a:r>
-              <a:t>Core Project Goals &amp; Clinical Engineering Vision</a:t>
+                <a:latin typeface="Arial"/>
+              </a:defRPr>
+            </a:pPr>
+            <a:r>
+              <a:t>What Did We Build to Solve This Problem?</a:t>
             </a:r>
           </a:p>
         </p:txBody>
@@ -4805,8 +4862,8 @@
         </p:nvSpPr>
         <p:spPr>
           <a:xfrm>
-            <a:off x="822960" y="1691640"/>
-            <a:ext cx="10545775" cy="1417320"/>
+            <a:off x="822960" y="1600200"/>
+            <a:ext cx="10545775" cy="1463040"/>
           </a:xfrm>
           <a:prstGeom prst="roundRect">
             <a:avLst/>
@@ -4816,7 +4873,7 @@
           </a:solidFill>
           <a:ln w="12700">
             <a:solidFill>
-              <a:srgbClr val="CBD5E1"/>
+              <a:srgbClr val="94A3B8"/>
             </a:solidFill>
           </a:ln>
         </p:spPr>
@@ -4850,17 +4907,19 @@
         </p:nvSpPr>
         <p:spPr>
           <a:xfrm>
-            <a:off x="1051560" y="1920240"/>
-            <a:ext cx="822960" cy="868680"/>
+            <a:off x="1051560" y="1856232"/>
+            <a:ext cx="777240" cy="868680"/>
           </a:xfrm>
           <a:prstGeom prst="roundRect">
             <a:avLst/>
           </a:prstGeom>
           <a:solidFill>
-            <a:srgbClr val="2563EB"/>
-          </a:solidFill>
-          <a:ln>
-            <a:noFill/>
+            <a:srgbClr val="F1F5F9"/>
+          </a:solidFill>
+          <a:ln w="19050">
+            <a:solidFill>
+              <a:srgbClr val="1D4ED8"/>
+            </a:solidFill>
           </a:ln>
         </p:spPr>
         <p:style>
@@ -4884,9 +4943,9 @@
             <a:pPr algn="ctr">
               <a:defRPr sz="2000" b="1">
                 <a:solidFill>
-                  <a:srgbClr val="FFFFFF"/>
-                </a:solidFill>
-                <a:latin typeface="Calibri"/>
+                  <a:srgbClr val="1D4ED8"/>
+                </a:solidFill>
+                <a:latin typeface="Arial"/>
               </a:defRPr>
             </a:pPr>
             <a:r>
@@ -4903,8 +4962,8 @@
         </p:nvSpPr>
         <p:spPr>
           <a:xfrm>
-            <a:off x="2057400" y="1828800"/>
-            <a:ext cx="9144000" cy="1143000"/>
+            <a:off x="2057400" y="1737360"/>
+            <a:ext cx="9144000" cy="1188720"/>
           </a:xfrm>
           <a:prstGeom prst="rect">
             <a:avLst/>
@@ -4918,15 +4977,15 @@
           <a:lstStyle/>
           <a:p>
             <a:pPr>
-              <a:defRPr sz="1400" b="1">
+              <a:defRPr sz="1350" b="1">
                 <a:solidFill>
                   <a:srgbClr val="0F172A"/>
                 </a:solidFill>
-                <a:latin typeface="Calibri"/>
-              </a:defRPr>
-            </a:pPr>
-            <a:r>
-              <a:t>Proactive AI-Driven Early Stress Detection</a:t>
+                <a:latin typeface="Arial"/>
+              </a:defRPr>
+            </a:pPr>
+            <a:r>
+              <a:t>Easy Daily Health Tracking</a:t>
             </a:r>
           </a:p>
           <a:p>
@@ -4934,15 +4993,15 @@
               <a:spcBef>
                 <a:spcPts val="400"/>
               </a:spcBef>
-              <a:defRPr sz="1150">
-                <a:solidFill>
-                  <a:srgbClr val="334155"/>
-                </a:solidFill>
-                <a:latin typeface="Calibri"/>
-              </a:defRPr>
-            </a:pPr>
-            <a:r>
-              <a:t>Engineer an automated behavioral telemetry and clinical monitoring system capable of predicting soldier psychological burnout before it leads to critical operational failure.</a:t>
+              <a:defRPr sz="1100">
+                <a:solidFill>
+                  <a:srgbClr val="1E293B"/>
+                </a:solidFill>
+                <a:latin typeface="Arial"/>
+              </a:defRPr>
+            </a:pPr>
+            <a:r>
+              <a:t>Build a simple website where every soldier can easily submit their daily sleep hours, duty stress, and heart rate in less than 30 seconds.</a:t>
             </a:r>
           </a:p>
         </p:txBody>
@@ -4955,8 +5014,8 @@
         </p:nvSpPr>
         <p:spPr>
           <a:xfrm>
-            <a:off x="822960" y="3291840"/>
-            <a:ext cx="10545775" cy="1417320"/>
+            <a:off x="822960" y="3246120"/>
+            <a:ext cx="10545775" cy="1463040"/>
           </a:xfrm>
           <a:prstGeom prst="roundRect">
             <a:avLst/>
@@ -4966,7 +5025,7 @@
           </a:solidFill>
           <a:ln w="12700">
             <a:solidFill>
-              <a:srgbClr val="CBD5E1"/>
+              <a:srgbClr val="94A3B8"/>
             </a:solidFill>
           </a:ln>
         </p:spPr>
@@ -5000,17 +5059,19 @@
         </p:nvSpPr>
         <p:spPr>
           <a:xfrm>
-            <a:off x="1051560" y="3520440"/>
-            <a:ext cx="822960" cy="868680"/>
+            <a:off x="1051560" y="3502152"/>
+            <a:ext cx="777240" cy="868680"/>
           </a:xfrm>
           <a:prstGeom prst="roundRect">
             <a:avLst/>
           </a:prstGeom>
           <a:solidFill>
-            <a:srgbClr val="0D9488"/>
-          </a:solidFill>
-          <a:ln>
-            <a:noFill/>
+            <a:srgbClr val="F1F5F9"/>
+          </a:solidFill>
+          <a:ln w="19050">
+            <a:solidFill>
+              <a:srgbClr val="0F766E"/>
+            </a:solidFill>
           </a:ln>
         </p:spPr>
         <p:style>
@@ -5034,9 +5095,9 @@
             <a:pPr algn="ctr">
               <a:defRPr sz="2000" b="1">
                 <a:solidFill>
-                  <a:srgbClr val="FFFFFF"/>
-                </a:solidFill>
-                <a:latin typeface="Calibri"/>
+                  <a:srgbClr val="0F766E"/>
+                </a:solidFill>
+                <a:latin typeface="Arial"/>
               </a:defRPr>
             </a:pPr>
             <a:r>
@@ -5053,8 +5114,8 @@
         </p:nvSpPr>
         <p:spPr>
           <a:xfrm>
-            <a:off x="2057400" y="3429000"/>
-            <a:ext cx="9144000" cy="1143000"/>
+            <a:off x="2057400" y="3383280"/>
+            <a:ext cx="9144000" cy="1188720"/>
           </a:xfrm>
           <a:prstGeom prst="rect">
             <a:avLst/>
@@ -5068,15 +5129,15 @@
           <a:lstStyle/>
           <a:p>
             <a:pPr>
-              <a:defRPr sz="1400" b="1">
+              <a:defRPr sz="1350" b="1">
                 <a:solidFill>
                   <a:srgbClr val="0F172A"/>
                 </a:solidFill>
-                <a:latin typeface="Calibri"/>
-              </a:defRPr>
-            </a:pPr>
-            <a:r>
-              <a:t>Automated Multi-Metric Triage Categorization</a:t>
+                <a:latin typeface="Arial"/>
+              </a:defRPr>
+            </a:pPr>
+            <a:r>
+              <a:t>Automatic Color Alert (Triage System)</a:t>
             </a:r>
           </a:p>
           <a:p>
@@ -5084,15 +5145,15 @@
               <a:spcBef>
                 <a:spcPts val="400"/>
               </a:spcBef>
-              <a:defRPr sz="1150">
-                <a:solidFill>
-                  <a:srgbClr val="334155"/>
-                </a:solidFill>
-                <a:latin typeface="Calibri"/>
-              </a:defRPr>
-            </a:pPr>
-            <a:r>
-              <a:t>Implement algorithmic classification dividing personnel into High, Medium, and Low risk tiers based on daily sleep, duty stress, heart rate, and squad morale.</a:t>
+              <a:defRPr sz="1100">
+                <a:solidFill>
+                  <a:srgbClr val="1E293B"/>
+                </a:solidFill>
+                <a:latin typeface="Arial"/>
+              </a:defRPr>
+            </a:pPr>
+            <a:r>
+              <a:t>Automatically categorize soldiers into Red (High Risk), Yellow (Medium Risk), and Green (Safe) based on their daily health scores.</a:t>
             </a:r>
           </a:p>
         </p:txBody>
@@ -5106,7 +5167,7 @@
         <p:spPr>
           <a:xfrm>
             <a:off x="822960" y="4892040"/>
-            <a:ext cx="10545775" cy="1417320"/>
+            <a:ext cx="10545775" cy="1463040"/>
           </a:xfrm>
           <a:prstGeom prst="roundRect">
             <a:avLst/>
@@ -5116,7 +5177,7 @@
           </a:solidFill>
           <a:ln w="12700">
             <a:solidFill>
-              <a:srgbClr val="CBD5E1"/>
+              <a:srgbClr val="94A3B8"/>
             </a:solidFill>
           </a:ln>
         </p:spPr>
@@ -5150,17 +5211,19 @@
         </p:nvSpPr>
         <p:spPr>
           <a:xfrm>
-            <a:off x="1051560" y="5120640"/>
-            <a:ext cx="822960" cy="868680"/>
+            <a:off x="1051560" y="5148072"/>
+            <a:ext cx="777240" cy="868680"/>
           </a:xfrm>
           <a:prstGeom prst="roundRect">
             <a:avLst/>
           </a:prstGeom>
           <a:solidFill>
-            <a:srgbClr val="0F172A"/>
-          </a:solidFill>
-          <a:ln>
-            <a:noFill/>
+            <a:srgbClr val="F1F5F9"/>
+          </a:solidFill>
+          <a:ln w="19050">
+            <a:solidFill>
+              <a:srgbClr val="0F172A"/>
+            </a:solidFill>
           </a:ln>
         </p:spPr>
         <p:style>
@@ -5184,9 +5247,9 @@
             <a:pPr algn="ctr">
               <a:defRPr sz="2000" b="1">
                 <a:solidFill>
-                  <a:srgbClr val="FFFFFF"/>
-                </a:solidFill>
-                <a:latin typeface="Calibri"/>
+                  <a:srgbClr val="0F172A"/>
+                </a:solidFill>
+                <a:latin typeface="Arial"/>
               </a:defRPr>
             </a:pPr>
             <a:r>
@@ -5204,7 +5267,7 @@
         <p:spPr>
           <a:xfrm>
             <a:off x="2057400" y="5029200"/>
-            <a:ext cx="9144000" cy="1143000"/>
+            <a:ext cx="9144000" cy="1188720"/>
           </a:xfrm>
           <a:prstGeom prst="rect">
             <a:avLst/>
@@ -5218,15 +5281,15 @@
           <a:lstStyle/>
           <a:p>
             <a:pPr>
-              <a:defRPr sz="1400" b="1">
+              <a:defRPr sz="1350" b="1">
                 <a:solidFill>
                   <a:srgbClr val="0F172A"/>
                 </a:solidFill>
-                <a:latin typeface="Calibri"/>
-              </a:defRPr>
-            </a:pPr>
-            <a:r>
-              <a:t>Instant Frontline De-Escalation &amp; Crisis Dispatch</a:t>
+                <a:latin typeface="Arial"/>
+              </a:defRPr>
+            </a:pPr>
+            <a:r>
+              <a:t>Instant Emergency Help &amp; Calming Tool</a:t>
             </a:r>
           </a:p>
           <a:p>
@@ -5234,15 +5297,15 @@
               <a:spcBef>
                 <a:spcPts val="400"/>
               </a:spcBef>
-              <a:defRPr sz="1150">
-                <a:solidFill>
-                  <a:srgbClr val="334155"/>
-                </a:solidFill>
-                <a:latin typeface="Calibri"/>
-              </a:defRPr>
-            </a:pPr>
-            <a:r>
-              <a:t>Provide immediate psychological stabilization through interactive 4-7-8 breathing exercises and direct 1-click Crisis SOS routing to military helpline 1902 and Tele-MANAS.</a:t>
+              <a:defRPr sz="1100">
+                <a:solidFill>
+                  <a:srgbClr val="1E293B"/>
+                </a:solidFill>
+                <a:latin typeface="Arial"/>
+              </a:defRPr>
+            </a:pPr>
+            <a:r>
+              <a:t>Provide a 1-click Crisis SOS call button to Army Helplines and an interactive 4-7-8 breathing exercise to calm rapid heartbeats and panic.</a:t>
             </a:r>
           </a:p>
         </p:txBody>
@@ -5255,7 +5318,7 @@
         </p:nvSpPr>
         <p:spPr>
           <a:xfrm>
-            <a:off x="822960" y="6400800"/>
+            <a:off x="822960" y="6446520"/>
             <a:ext cx="10515600" cy="320040"/>
           </a:xfrm>
           <a:prstGeom prst="rect">
@@ -5274,11 +5337,11 @@
                 <a:solidFill>
                   <a:srgbClr val="64748B"/>
                 </a:solidFill>
-                <a:latin typeface="Calibri"/>
-              </a:defRPr>
-            </a:pPr>
-            <a:r>
-              <a:t>APPS - AI Predictive Personnel Stress &amp; Welfare Monitoring Systems | Computer Science &amp; Business Systems</a:t>
+                <a:latin typeface="Arial"/>
+              </a:defRPr>
+            </a:pPr>
+            <a:r>
+              <a:t>APPS - Final Year Mini Project | DHARUN.M (CSBS) | Slide 3 of 10</a:t>
             </a:r>
           </a:p>
         </p:txBody>
@@ -5316,7 +5379,7 @@
             <a:avLst/>
           </a:prstGeom>
           <a:solidFill>
-            <a:srgbClr val="F8FAFC"/>
+            <a:srgbClr val="FFFFFF"/>
           </a:solidFill>
           <a:ln>
             <a:noFill/>
@@ -5352,18 +5415,18 @@
         </p:nvSpPr>
         <p:spPr>
           <a:xfrm>
-            <a:off x="822960" y="457200"/>
-            <a:ext cx="2926080" cy="320040"/>
+            <a:off x="822960" y="411480"/>
+            <a:ext cx="3200400" cy="320040"/>
           </a:xfrm>
           <a:prstGeom prst="roundRect">
             <a:avLst/>
           </a:prstGeom>
           <a:solidFill>
-            <a:srgbClr val="EFF6FF"/>
+            <a:srgbClr val="F1F5F9"/>
           </a:solidFill>
           <a:ln>
             <a:solidFill>
-              <a:srgbClr val="BFDBFE"/>
+              <a:srgbClr val="94A3B8"/>
             </a:solidFill>
           </a:ln>
         </p:spPr>
@@ -5388,13 +5451,13 @@
             <a:pPr algn="ctr">
               <a:defRPr sz="950" b="1">
                 <a:solidFill>
-                  <a:srgbClr val="2563EB"/>
-                </a:solidFill>
-                <a:latin typeface="Calibri"/>
-              </a:defRPr>
-            </a:pPr>
-            <a:r>
-              <a:t>SLIDE 04 | ARCHITECTURE</a:t>
+                  <a:srgbClr val="1D4ED8"/>
+                </a:solidFill>
+                <a:latin typeface="Arial"/>
+              </a:defRPr>
+            </a:pPr>
+            <a:r>
+              <a:t>SLIDE 04 | SYSTEM ARCHITECTURE</a:t>
             </a:r>
           </a:p>
         </p:txBody>
@@ -5407,7 +5470,7 @@
         </p:nvSpPr>
         <p:spPr>
           <a:xfrm>
-            <a:off x="822960" y="822960"/>
+            <a:off x="822960" y="777240"/>
             <a:ext cx="10515600" cy="731520"/>
           </a:xfrm>
           <a:prstGeom prst="rect">
@@ -5422,15 +5485,15 @@
           <a:lstStyle/>
           <a:p>
             <a:pPr>
-              <a:defRPr sz="2200" b="1">
+              <a:defRPr sz="2100" b="1">
                 <a:solidFill>
                   <a:srgbClr val="0F172A"/>
                 </a:solidFill>
-                <a:latin typeface="Calibri"/>
-              </a:defRPr>
-            </a:pPr>
-            <a:r>
-              <a:t>3-Tier Role Hierarchy &amp; Cloud Infrastructure</a:t>
+                <a:latin typeface="Arial"/>
+              </a:defRPr>
+            </a:pPr>
+            <a:r>
+              <a:t>How the System Works: 3 Roles &amp; Cloud Setup</a:t>
             </a:r>
           </a:p>
         </p:txBody>
@@ -5443,8 +5506,8 @@
         </p:nvSpPr>
         <p:spPr>
           <a:xfrm>
-            <a:off x="822960" y="1691640"/>
-            <a:ext cx="10545775" cy="1417320"/>
+            <a:off x="822960" y="1600200"/>
+            <a:ext cx="10545775" cy="1463040"/>
           </a:xfrm>
           <a:prstGeom prst="roundRect">
             <a:avLst/>
@@ -5454,7 +5517,7 @@
           </a:solidFill>
           <a:ln w="12700">
             <a:solidFill>
-              <a:srgbClr val="CBD5E1"/>
+              <a:srgbClr val="94A3B8"/>
             </a:solidFill>
           </a:ln>
         </p:spPr>
@@ -5488,17 +5551,19 @@
         </p:nvSpPr>
         <p:spPr>
           <a:xfrm>
-            <a:off x="1051560" y="1920240"/>
-            <a:ext cx="822960" cy="868680"/>
+            <a:off x="1051560" y="1856232"/>
+            <a:ext cx="777240" cy="868680"/>
           </a:xfrm>
           <a:prstGeom prst="roundRect">
             <a:avLst/>
           </a:prstGeom>
           <a:solidFill>
-            <a:srgbClr val="2563EB"/>
-          </a:solidFill>
-          <a:ln>
-            <a:noFill/>
+            <a:srgbClr val="F1F5F9"/>
+          </a:solidFill>
+          <a:ln w="19050">
+            <a:solidFill>
+              <a:srgbClr val="1D4ED8"/>
+            </a:solidFill>
           </a:ln>
         </p:spPr>
         <p:style>
@@ -5522,9 +5587,9 @@
             <a:pPr algn="ctr">
               <a:defRPr sz="2000" b="1">
                 <a:solidFill>
-                  <a:srgbClr val="FFFFFF"/>
-                </a:solidFill>
-                <a:latin typeface="Calibri"/>
+                  <a:srgbClr val="1D4ED8"/>
+                </a:solidFill>
+                <a:latin typeface="Arial"/>
               </a:defRPr>
             </a:pPr>
             <a:r>
@@ -5541,8 +5606,8 @@
         </p:nvSpPr>
         <p:spPr>
           <a:xfrm>
-            <a:off x="2057400" y="1828800"/>
-            <a:ext cx="9144000" cy="1143000"/>
+            <a:off x="2057400" y="1737360"/>
+            <a:ext cx="9144000" cy="1188720"/>
           </a:xfrm>
           <a:prstGeom prst="rect">
             <a:avLst/>
@@ -5556,15 +5621,15 @@
           <a:lstStyle/>
           <a:p>
             <a:pPr>
-              <a:defRPr sz="1400" b="1">
+              <a:defRPr sz="1350" b="1">
                 <a:solidFill>
                   <a:srgbClr val="0F172A"/>
                 </a:solidFill>
-                <a:latin typeface="Calibri"/>
-              </a:defRPr>
-            </a:pPr>
-            <a:r>
-              <a:t>Tri-Level Military Role-Based Access Control (RBAC)</a:t>
+                <a:latin typeface="Arial"/>
+              </a:defRPr>
+            </a:pPr>
+            <a:r>
+              <a:t>Three Clear User Roles</a:t>
             </a:r>
           </a:p>
           <a:p>
@@ -5572,15 +5637,15 @@
               <a:spcBef>
                 <a:spcPts val="400"/>
               </a:spcBef>
-              <a:defRPr sz="1150">
-                <a:solidFill>
-                  <a:srgbClr val="334155"/>
-                </a:solidFill>
-                <a:latin typeface="Calibri"/>
-              </a:defRPr>
-            </a:pPr>
-            <a:r>
-              <a:t>Strict operational separation across Personnel (Daily survey &amp; SOS), Welfare Officers (Triage roster &amp; Clinical notes), and Senior Command HQ (Analytics &amp; PIN control).</a:t>
+              <a:defRPr sz="1100">
+                <a:solidFill>
+                  <a:srgbClr val="1E293B"/>
+                </a:solidFill>
+                <a:latin typeface="Arial"/>
+              </a:defRPr>
+            </a:pPr>
+            <a:r>
+              <a:t>Strict division of duties: Soldiers log daily data; Welfare Officers monitor risk rosters and give counseling; Senior Admins manage overall Army stats.</a:t>
             </a:r>
           </a:p>
         </p:txBody>
@@ -5593,8 +5658,8 @@
         </p:nvSpPr>
         <p:spPr>
           <a:xfrm>
-            <a:off x="822960" y="3291840"/>
-            <a:ext cx="10545775" cy="1417320"/>
+            <a:off x="822960" y="3246120"/>
+            <a:ext cx="10545775" cy="1463040"/>
           </a:xfrm>
           <a:prstGeom prst="roundRect">
             <a:avLst/>
@@ -5604,7 +5669,7 @@
           </a:solidFill>
           <a:ln w="12700">
             <a:solidFill>
-              <a:srgbClr val="CBD5E1"/>
+              <a:srgbClr val="94A3B8"/>
             </a:solidFill>
           </a:ln>
         </p:spPr>
@@ -5638,17 +5703,19 @@
         </p:nvSpPr>
         <p:spPr>
           <a:xfrm>
-            <a:off x="1051560" y="3520440"/>
-            <a:ext cx="822960" cy="868680"/>
+            <a:off x="1051560" y="3502152"/>
+            <a:ext cx="777240" cy="868680"/>
           </a:xfrm>
           <a:prstGeom prst="roundRect">
             <a:avLst/>
           </a:prstGeom>
           <a:solidFill>
-            <a:srgbClr val="0D9488"/>
-          </a:solidFill>
-          <a:ln>
-            <a:noFill/>
+            <a:srgbClr val="F1F5F9"/>
+          </a:solidFill>
+          <a:ln w="19050">
+            <a:solidFill>
+              <a:srgbClr val="0F766E"/>
+            </a:solidFill>
           </a:ln>
         </p:spPr>
         <p:style>
@@ -5672,9 +5739,9 @@
             <a:pPr algn="ctr">
               <a:defRPr sz="2000" b="1">
                 <a:solidFill>
-                  <a:srgbClr val="FFFFFF"/>
-                </a:solidFill>
-                <a:latin typeface="Calibri"/>
+                  <a:srgbClr val="0F766E"/>
+                </a:solidFill>
+                <a:latin typeface="Arial"/>
               </a:defRPr>
             </a:pPr>
             <a:r>
@@ -5691,8 +5758,8 @@
         </p:nvSpPr>
         <p:spPr>
           <a:xfrm>
-            <a:off x="2057400" y="3429000"/>
-            <a:ext cx="9144000" cy="1143000"/>
+            <a:off x="2057400" y="3383280"/>
+            <a:ext cx="9144000" cy="1188720"/>
           </a:xfrm>
           <a:prstGeom prst="rect">
             <a:avLst/>
@@ -5706,15 +5773,15 @@
           <a:lstStyle/>
           <a:p>
             <a:pPr>
-              <a:defRPr sz="1400" b="1">
+              <a:defRPr sz="1350" b="1">
                 <a:solidFill>
                   <a:srgbClr val="0F172A"/>
                 </a:solidFill>
-                <a:latin typeface="Calibri"/>
-              </a:defRPr>
-            </a:pPr>
-            <a:r>
-              <a:t>Serverless Backend with Vercel Cloud Blob Persistence</a:t>
+                <a:latin typeface="Arial"/>
+              </a:defRPr>
+            </a:pPr>
+            <a:r>
+              <a:t>Safe Cloud Database with Zero Data Loss</a:t>
             </a:r>
           </a:p>
           <a:p>
@@ -5722,15 +5789,15 @@
               <a:spcBef>
                 <a:spcPts val="400"/>
               </a:spcBef>
-              <a:defRPr sz="1150">
-                <a:solidFill>
-                  <a:srgbClr val="334155"/>
-                </a:solidFill>
-                <a:latin typeface="Calibri"/>
-              </a:defRPr>
-            </a:pPr>
-            <a:r>
-              <a:t>Python Flask WSGI microservice integrated with private Vercel Blob storage, ensuring zero database loss across ephemeral cloud cold-boots through automated snapshot hydration.</a:t>
+              <a:defRPr sz="1100">
+                <a:solidFill>
+                  <a:srgbClr val="1E293B"/>
+                </a:solidFill>
+                <a:latin typeface="Arial"/>
+              </a:defRPr>
+            </a:pPr>
+            <a:r>
+              <a:t>Developed using Python Flask and SQLite, connected to private Vercel cloud storage so that database records are permanently saved without losing data.</a:t>
             </a:r>
           </a:p>
         </p:txBody>
@@ -5744,7 +5811,7 @@
         <p:spPr>
           <a:xfrm>
             <a:off x="822960" y="4892040"/>
-            <a:ext cx="10545775" cy="1417320"/>
+            <a:ext cx="10545775" cy="1463040"/>
           </a:xfrm>
           <a:prstGeom prst="roundRect">
             <a:avLst/>
@@ -5754,7 +5821,7 @@
           </a:solidFill>
           <a:ln w="12700">
             <a:solidFill>
-              <a:srgbClr val="CBD5E1"/>
+              <a:srgbClr val="94A3B8"/>
             </a:solidFill>
           </a:ln>
         </p:spPr>
@@ -5788,17 +5855,19 @@
         </p:nvSpPr>
         <p:spPr>
           <a:xfrm>
-            <a:off x="1051560" y="5120640"/>
-            <a:ext cx="822960" cy="868680"/>
+            <a:off x="1051560" y="5148072"/>
+            <a:ext cx="777240" cy="868680"/>
           </a:xfrm>
           <a:prstGeom prst="roundRect">
             <a:avLst/>
           </a:prstGeom>
           <a:solidFill>
-            <a:srgbClr val="0F172A"/>
-          </a:solidFill>
-          <a:ln>
-            <a:noFill/>
+            <a:srgbClr val="F1F5F9"/>
+          </a:solidFill>
+          <a:ln w="19050">
+            <a:solidFill>
+              <a:srgbClr val="0F172A"/>
+            </a:solidFill>
           </a:ln>
         </p:spPr>
         <p:style>
@@ -5822,9 +5891,9 @@
             <a:pPr algn="ctr">
               <a:defRPr sz="2000" b="1">
                 <a:solidFill>
-                  <a:srgbClr val="FFFFFF"/>
-                </a:solidFill>
-                <a:latin typeface="Calibri"/>
+                  <a:srgbClr val="0F172A"/>
+                </a:solidFill>
+                <a:latin typeface="Arial"/>
               </a:defRPr>
             </a:pPr>
             <a:r>
@@ -5842,7 +5911,7 @@
         <p:spPr>
           <a:xfrm>
             <a:off x="2057400" y="5029200"/>
-            <a:ext cx="9144000" cy="1143000"/>
+            <a:ext cx="9144000" cy="1188720"/>
           </a:xfrm>
           <a:prstGeom prst="rect">
             <a:avLst/>
@@ -5856,15 +5925,15 @@
           <a:lstStyle/>
           <a:p>
             <a:pPr>
-              <a:defRPr sz="1400" b="1">
+              <a:defRPr sz="1350" b="1">
                 <a:solidFill>
                   <a:srgbClr val="0F172A"/>
                 </a:solidFill>
-                <a:latin typeface="Calibri"/>
-              </a:defRPr>
-            </a:pPr>
-            <a:r>
-              <a:t>Dual-Screen Responsive Design (Laptop &amp; Mobile)</a:t>
+                <a:latin typeface="Arial"/>
+              </a:defRPr>
+            </a:pPr>
+            <a:r>
+              <a:t>Works Smoothly on Mobile &amp; Laptop</a:t>
             </a:r>
           </a:p>
           <a:p>
@@ -5872,15 +5941,15 @@
               <a:spcBef>
                 <a:spcPts val="400"/>
               </a:spcBef>
-              <a:defRPr sz="1150">
-                <a:solidFill>
-                  <a:srgbClr val="334155"/>
-                </a:solidFill>
-                <a:latin typeface="Calibri"/>
-              </a:defRPr>
-            </a:pPr>
-            <a:r>
-              <a:t>Executive 2-column laptop dashboard (1.15fr : 0.85fr grid) paired with a touch-optimized mobile slide-out drawer navigation with zero horizontal overflow.</a:t>
+              <a:defRPr sz="1100">
+                <a:solidFill>
+                  <a:srgbClr val="1E293B"/>
+                </a:solidFill>
+                <a:latin typeface="Arial"/>
+              </a:defRPr>
+            </a:pPr>
+            <a:r>
+              <a:t>Designed with a clean mobile slide-out menu for smartphones and an executive two-column dashboard for laptops with zero horizontal scrolling.</a:t>
             </a:r>
           </a:p>
         </p:txBody>
@@ -5893,7 +5962,7 @@
         </p:nvSpPr>
         <p:spPr>
           <a:xfrm>
-            <a:off x="822960" y="6400800"/>
+            <a:off x="822960" y="6446520"/>
             <a:ext cx="10515600" cy="320040"/>
           </a:xfrm>
           <a:prstGeom prst="rect">
@@ -5912,11 +5981,11 @@
                 <a:solidFill>
                   <a:srgbClr val="64748B"/>
                 </a:solidFill>
-                <a:latin typeface="Calibri"/>
-              </a:defRPr>
-            </a:pPr>
-            <a:r>
-              <a:t>APPS - AI Predictive Personnel Stress &amp; Welfare Monitoring Systems | Computer Science &amp; Business Systems</a:t>
+                <a:latin typeface="Arial"/>
+              </a:defRPr>
+            </a:pPr>
+            <a:r>
+              <a:t>APPS - Final Year Mini Project | DHARUN.M (CSBS) | Slide 4 of 10</a:t>
             </a:r>
           </a:p>
         </p:txBody>
@@ -5954,7 +6023,7 @@
             <a:avLst/>
           </a:prstGeom>
           <a:solidFill>
-            <a:srgbClr val="F8FAFC"/>
+            <a:srgbClr val="FFFFFF"/>
           </a:solidFill>
           <a:ln>
             <a:noFill/>
@@ -5990,18 +6059,18 @@
         </p:nvSpPr>
         <p:spPr>
           <a:xfrm>
-            <a:off x="822960" y="457200"/>
-            <a:ext cx="2926080" cy="320040"/>
+            <a:off x="822960" y="411480"/>
+            <a:ext cx="3200400" cy="320040"/>
           </a:xfrm>
           <a:prstGeom prst="roundRect">
             <a:avLst/>
           </a:prstGeom>
           <a:solidFill>
-            <a:srgbClr val="EFF6FF"/>
+            <a:srgbClr val="F1F5F9"/>
           </a:solidFill>
           <a:ln>
             <a:solidFill>
-              <a:srgbClr val="BFDBFE"/>
+              <a:srgbClr val="94A3B8"/>
             </a:solidFill>
           </a:ln>
         </p:spPr>
@@ -6026,9 +6095,9 @@
             <a:pPr algn="ctr">
               <a:defRPr sz="950" b="1">
                 <a:solidFill>
-                  <a:srgbClr val="2563EB"/>
-                </a:solidFill>
-                <a:latin typeface="Calibri"/>
+                  <a:srgbClr val="1D4ED8"/>
+                </a:solidFill>
+                <a:latin typeface="Arial"/>
               </a:defRPr>
             </a:pPr>
             <a:r>
@@ -6045,7 +6114,7 @@
         </p:nvSpPr>
         <p:spPr>
           <a:xfrm>
-            <a:off x="822960" y="822960"/>
+            <a:off x="822960" y="777240"/>
             <a:ext cx="10515600" cy="731520"/>
           </a:xfrm>
           <a:prstGeom prst="rect">
@@ -6060,15 +6129,15 @@
           <a:lstStyle/>
           <a:p>
             <a:pPr>
-              <a:defRPr sz="2200" b="1">
+              <a:defRPr sz="2100" b="1">
                 <a:solidFill>
                   <a:srgbClr val="0F172A"/>
                 </a:solidFill>
-                <a:latin typeface="Calibri"/>
-              </a:defRPr>
-            </a:pPr>
-            <a:r>
-              <a:t>Soldier Daily Self-Assessment &amp; Biometric Tracking</a:t>
+                <a:latin typeface="Arial"/>
+              </a:defRPr>
+            </a:pPr>
+            <a:r>
+              <a:t>How a Soldier Uses the System Daily</a:t>
             </a:r>
           </a:p>
         </p:txBody>
@@ -6081,8 +6150,8 @@
         </p:nvSpPr>
         <p:spPr>
           <a:xfrm>
-            <a:off x="822960" y="1691640"/>
-            <a:ext cx="10545775" cy="1417320"/>
+            <a:off x="822960" y="1600200"/>
+            <a:ext cx="10545775" cy="1463040"/>
           </a:xfrm>
           <a:prstGeom prst="roundRect">
             <a:avLst/>
@@ -6092,7 +6161,7 @@
           </a:solidFill>
           <a:ln w="12700">
             <a:solidFill>
-              <a:srgbClr val="CBD5E1"/>
+              <a:srgbClr val="94A3B8"/>
             </a:solidFill>
           </a:ln>
         </p:spPr>
@@ -6126,17 +6195,19 @@
         </p:nvSpPr>
         <p:spPr>
           <a:xfrm>
-            <a:off x="1051560" y="1920240"/>
-            <a:ext cx="822960" cy="868680"/>
+            <a:off x="1051560" y="1856232"/>
+            <a:ext cx="777240" cy="868680"/>
           </a:xfrm>
           <a:prstGeom prst="roundRect">
             <a:avLst/>
           </a:prstGeom>
           <a:solidFill>
-            <a:srgbClr val="2563EB"/>
-          </a:solidFill>
-          <a:ln>
-            <a:noFill/>
+            <a:srgbClr val="F1F5F9"/>
+          </a:solidFill>
+          <a:ln w="19050">
+            <a:solidFill>
+              <a:srgbClr val="1D4ED8"/>
+            </a:solidFill>
           </a:ln>
         </p:spPr>
         <p:style>
@@ -6160,9 +6231,9 @@
             <a:pPr algn="ctr">
               <a:defRPr sz="2000" b="1">
                 <a:solidFill>
-                  <a:srgbClr val="FFFFFF"/>
-                </a:solidFill>
-                <a:latin typeface="Calibri"/>
+                  <a:srgbClr val="1D4ED8"/>
+                </a:solidFill>
+                <a:latin typeface="Arial"/>
               </a:defRPr>
             </a:pPr>
             <a:r>
@@ -6179,8 +6250,8 @@
         </p:nvSpPr>
         <p:spPr>
           <a:xfrm>
-            <a:off x="2057400" y="1828800"/>
-            <a:ext cx="9144000" cy="1143000"/>
+            <a:off x="2057400" y="1737360"/>
+            <a:ext cx="9144000" cy="1188720"/>
           </a:xfrm>
           <a:prstGeom prst="rect">
             <a:avLst/>
@@ -6194,15 +6265,15 @@
           <a:lstStyle/>
           <a:p>
             <a:pPr>
-              <a:defRPr sz="1400" b="1">
+              <a:defRPr sz="1350" b="1">
                 <a:solidFill>
                   <a:srgbClr val="0F172A"/>
                 </a:solidFill>
-                <a:latin typeface="Calibri"/>
-              </a:defRPr>
-            </a:pPr>
-            <a:r>
-              <a:t>4-Dimensional Daily Health Telemetry Capture</a:t>
+                <a:latin typeface="Arial"/>
+              </a:defRPr>
+            </a:pPr>
+            <a:r>
+              <a:t>4 Quick Daily Health Inputs</a:t>
             </a:r>
           </a:p>
           <a:p>
@@ -6210,15 +6281,15 @@
               <a:spcBef>
                 <a:spcPts val="400"/>
               </a:spcBef>
-              <a:defRPr sz="1150">
-                <a:solidFill>
-                  <a:srgbClr val="334155"/>
-                </a:solidFill>
-                <a:latin typeface="Calibri"/>
-              </a:defRPr>
-            </a:pPr>
-            <a:r>
-              <a:t>Personnel log daily sleep duration (0-12h), operational duty stress (1-10 dynamic slider), physical resting heart rate (bpm), and squad/family support level.</a:t>
+              <a:defRPr sz="1100">
+                <a:solidFill>
+                  <a:srgbClr val="1E293B"/>
+                </a:solidFill>
+                <a:latin typeface="Arial"/>
+              </a:defRPr>
+            </a:pPr>
+            <a:r>
+              <a:t>Soldier enters only four basic numbers: Sleep hours (0-12), Operational stress slider (1-10), Heart rate (bpm), and Squad morale (1-5).</a:t>
             </a:r>
           </a:p>
         </p:txBody>
@@ -6231,8 +6302,8 @@
         </p:nvSpPr>
         <p:spPr>
           <a:xfrm>
-            <a:off x="822960" y="3291840"/>
-            <a:ext cx="10545775" cy="1417320"/>
+            <a:off x="822960" y="3246120"/>
+            <a:ext cx="10545775" cy="1463040"/>
           </a:xfrm>
           <a:prstGeom prst="roundRect">
             <a:avLst/>
@@ -6242,7 +6313,7 @@
           </a:solidFill>
           <a:ln w="12700">
             <a:solidFill>
-              <a:srgbClr val="CBD5E1"/>
+              <a:srgbClr val="94A3B8"/>
             </a:solidFill>
           </a:ln>
         </p:spPr>
@@ -6276,17 +6347,19 @@
         </p:nvSpPr>
         <p:spPr>
           <a:xfrm>
-            <a:off x="1051560" y="3520440"/>
-            <a:ext cx="822960" cy="868680"/>
+            <a:off x="1051560" y="3502152"/>
+            <a:ext cx="777240" cy="868680"/>
           </a:xfrm>
           <a:prstGeom prst="roundRect">
             <a:avLst/>
           </a:prstGeom>
           <a:solidFill>
-            <a:srgbClr val="0D9488"/>
-          </a:solidFill>
-          <a:ln>
-            <a:noFill/>
+            <a:srgbClr val="F1F5F9"/>
+          </a:solidFill>
+          <a:ln w="19050">
+            <a:solidFill>
+              <a:srgbClr val="0F766E"/>
+            </a:solidFill>
           </a:ln>
         </p:spPr>
         <p:style>
@@ -6310,9 +6383,9 @@
             <a:pPr algn="ctr">
               <a:defRPr sz="2000" b="1">
                 <a:solidFill>
-                  <a:srgbClr val="FFFFFF"/>
-                </a:solidFill>
-                <a:latin typeface="Calibri"/>
+                  <a:srgbClr val="0F766E"/>
+                </a:solidFill>
+                <a:latin typeface="Arial"/>
               </a:defRPr>
             </a:pPr>
             <a:r>
@@ -6329,8 +6402,8 @@
         </p:nvSpPr>
         <p:spPr>
           <a:xfrm>
-            <a:off x="2057400" y="3429000"/>
-            <a:ext cx="9144000" cy="1143000"/>
+            <a:off x="2057400" y="3383280"/>
+            <a:ext cx="9144000" cy="1188720"/>
           </a:xfrm>
           <a:prstGeom prst="rect">
             <a:avLst/>
@@ -6344,15 +6417,15 @@
           <a:lstStyle/>
           <a:p>
             <a:pPr>
-              <a:defRPr sz="1400" b="1">
+              <a:defRPr sz="1350" b="1">
                 <a:solidFill>
                   <a:srgbClr val="0F172A"/>
                 </a:solidFill>
-                <a:latin typeface="Calibri"/>
-              </a:defRPr>
-            </a:pPr>
-            <a:r>
-              <a:t>Smartwatch &amp; BLE Sensor Simulation Engine</a:t>
+                <a:latin typeface="Arial"/>
+              </a:defRPr>
+            </a:pPr>
+            <a:r>
+              <a:t>Smartwatch One-Click Sync</a:t>
             </a:r>
           </a:p>
           <a:p>
@@ -6360,15 +6433,15 @@
               <a:spcBef>
                 <a:spcPts val="400"/>
               </a:spcBef>
-              <a:defRPr sz="1150">
-                <a:solidFill>
-                  <a:srgbClr val="334155"/>
-                </a:solidFill>
-                <a:latin typeface="Calibri"/>
-              </a:defRPr>
-            </a:pPr>
-            <a:r>
-              <a:t>One-click telemetry synchronization that automatically loads realistic wearable sensor data into daily assessment fields, reducing soldier reporting friction.</a:t>
+              <a:defRPr sz="1100">
+                <a:solidFill>
+                  <a:srgbClr val="1E293B"/>
+                </a:solidFill>
+                <a:latin typeface="Arial"/>
+              </a:defRPr>
+            </a:pPr>
+            <a:r>
+              <a:t>A single 'Sync Smartwatch' button automatically fills sensor heart rate and sleep values so the soldier does not need to type manually.</a:t>
             </a:r>
           </a:p>
         </p:txBody>
@@ -6382,7 +6455,7 @@
         <p:spPr>
           <a:xfrm>
             <a:off x="822960" y="4892040"/>
-            <a:ext cx="10545775" cy="1417320"/>
+            <a:ext cx="10545775" cy="1463040"/>
           </a:xfrm>
           <a:prstGeom prst="roundRect">
             <a:avLst/>
@@ -6392,7 +6465,7 @@
           </a:solidFill>
           <a:ln w="12700">
             <a:solidFill>
-              <a:srgbClr val="CBD5E1"/>
+              <a:srgbClr val="94A3B8"/>
             </a:solidFill>
           </a:ln>
         </p:spPr>
@@ -6426,17 +6499,19 @@
         </p:nvSpPr>
         <p:spPr>
           <a:xfrm>
-            <a:off x="1051560" y="5120640"/>
-            <a:ext cx="822960" cy="868680"/>
+            <a:off x="1051560" y="5148072"/>
+            <a:ext cx="777240" cy="868680"/>
           </a:xfrm>
           <a:prstGeom prst="roundRect">
             <a:avLst/>
           </a:prstGeom>
           <a:solidFill>
-            <a:srgbClr val="0F172A"/>
-          </a:solidFill>
-          <a:ln>
-            <a:noFill/>
+            <a:srgbClr val="F1F5F9"/>
+          </a:solidFill>
+          <a:ln w="19050">
+            <a:solidFill>
+              <a:srgbClr val="0F172A"/>
+            </a:solidFill>
           </a:ln>
         </p:spPr>
         <p:style>
@@ -6460,9 +6535,9 @@
             <a:pPr algn="ctr">
               <a:defRPr sz="2000" b="1">
                 <a:solidFill>
-                  <a:srgbClr val="FFFFFF"/>
-                </a:solidFill>
-                <a:latin typeface="Calibri"/>
+                  <a:srgbClr val="0F172A"/>
+                </a:solidFill>
+                <a:latin typeface="Arial"/>
               </a:defRPr>
             </a:pPr>
             <a:r>
@@ -6480,7 +6555,7 @@
         <p:spPr>
           <a:xfrm>
             <a:off x="2057400" y="5029200"/>
-            <a:ext cx="9144000" cy="1143000"/>
+            <a:ext cx="9144000" cy="1188720"/>
           </a:xfrm>
           <a:prstGeom prst="rect">
             <a:avLst/>
@@ -6494,15 +6569,15 @@
           <a:lstStyle/>
           <a:p>
             <a:pPr>
-              <a:defRPr sz="1400" b="1">
+              <a:defRPr sz="1350" b="1">
                 <a:solidFill>
                   <a:srgbClr val="0F172A"/>
                 </a:solidFill>
-                <a:latin typeface="Calibri"/>
-              </a:defRPr>
-            </a:pPr>
-            <a:r>
-              <a:t>Gamified Morale Badges &amp; Habit Formation Streaks</a:t>
+                <a:latin typeface="Arial"/>
+              </a:defRPr>
+            </a:pPr>
+            <a:r>
+              <a:t>Daily Streak &amp; Achievement Badges</a:t>
             </a:r>
           </a:p>
           <a:p>
@@ -6510,15 +6585,15 @@
               <a:spcBef>
                 <a:spcPts val="400"/>
               </a:spcBef>
-              <a:defRPr sz="1150">
-                <a:solidFill>
-                  <a:srgbClr val="334155"/>
-                </a:solidFill>
-                <a:latin typeface="Calibri"/>
-              </a:defRPr>
-            </a:pPr>
-            <a:r>
-              <a:t>Unlocks military achievement milestones such as 'Mental Resilience Sentinel' and tracks consecutive daily streaks to foster positive mental self-care habits.</a:t>
+              <a:defRPr sz="1100">
+                <a:solidFill>
+                  <a:srgbClr val="1E293B"/>
+                </a:solidFill>
+                <a:latin typeface="Arial"/>
+              </a:defRPr>
+            </a:pPr>
+            <a:r>
+              <a:t>App rewards consecutive daily entries with positive streak counts and military badges (like 'Iron Mind') to encourage daily self-care habits.</a:t>
             </a:r>
           </a:p>
         </p:txBody>
@@ -6531,7 +6606,7 @@
         </p:nvSpPr>
         <p:spPr>
           <a:xfrm>
-            <a:off x="822960" y="6400800"/>
+            <a:off x="822960" y="6446520"/>
             <a:ext cx="10515600" cy="320040"/>
           </a:xfrm>
           <a:prstGeom prst="rect">
@@ -6550,11 +6625,11 @@
                 <a:solidFill>
                   <a:srgbClr val="64748B"/>
                 </a:solidFill>
-                <a:latin typeface="Calibri"/>
-              </a:defRPr>
-            </a:pPr>
-            <a:r>
-              <a:t>APPS - AI Predictive Personnel Stress &amp; Welfare Monitoring Systems | Computer Science &amp; Business Systems</a:t>
+                <a:latin typeface="Arial"/>
+              </a:defRPr>
+            </a:pPr>
+            <a:r>
+              <a:t>APPS - Final Year Mini Project | DHARUN.M (CSBS) | Slide 5 of 10</a:t>
             </a:r>
           </a:p>
         </p:txBody>
@@ -6592,7 +6667,7 @@
             <a:avLst/>
           </a:prstGeom>
           <a:solidFill>
-            <a:srgbClr val="F8FAFC"/>
+            <a:srgbClr val="FFFFFF"/>
           </a:solidFill>
           <a:ln>
             <a:noFill/>
@@ -6628,18 +6703,18 @@
         </p:nvSpPr>
         <p:spPr>
           <a:xfrm>
-            <a:off x="822960" y="457200"/>
-            <a:ext cx="2926080" cy="320040"/>
+            <a:off x="822960" y="411480"/>
+            <a:ext cx="3200400" cy="320040"/>
           </a:xfrm>
           <a:prstGeom prst="roundRect">
             <a:avLst/>
           </a:prstGeom>
           <a:solidFill>
-            <a:srgbClr val="EFF6FF"/>
+            <a:srgbClr val="F1F5F9"/>
           </a:solidFill>
           <a:ln>
             <a:solidFill>
-              <a:srgbClr val="BFDBFE"/>
+              <a:srgbClr val="94A3B8"/>
             </a:solidFill>
           </a:ln>
         </p:spPr>
@@ -6664,13 +6739,13 @@
             <a:pPr algn="ctr">
               <a:defRPr sz="950" b="1">
                 <a:solidFill>
-                  <a:srgbClr val="2563EB"/>
-                </a:solidFill>
-                <a:latin typeface="Calibri"/>
-              </a:defRPr>
-            </a:pPr>
-            <a:r>
-              <a:t>SLIDE 06 | CLINICAL INTELLIGENCE</a:t>
+                  <a:srgbClr val="1D4ED8"/>
+                </a:solidFill>
+                <a:latin typeface="Arial"/>
+              </a:defRPr>
+            </a:pPr>
+            <a:r>
+              <a:t>SLIDE 06 | SMART HEALTH LOGIC</a:t>
             </a:r>
           </a:p>
         </p:txBody>
@@ -6683,7 +6758,7 @@
         </p:nvSpPr>
         <p:spPr>
           <a:xfrm>
-            <a:off x="822960" y="822960"/>
+            <a:off x="822960" y="777240"/>
             <a:ext cx="10515600" cy="731520"/>
           </a:xfrm>
           <a:prstGeom prst="rect">
@@ -6698,15 +6773,15 @@
           <a:lstStyle/>
           <a:p>
             <a:pPr>
-              <a:defRPr sz="2200" b="1">
+              <a:defRPr sz="2100" b="1">
                 <a:solidFill>
                   <a:srgbClr val="0F172A"/>
                 </a:solidFill>
-                <a:latin typeface="Calibri"/>
-              </a:defRPr>
-            </a:pPr>
-            <a:r>
-              <a:t>Automated Risk Triage &amp; Sleep Debt Analytics</a:t>
+                <a:latin typeface="Arial"/>
+              </a:defRPr>
+            </a:pPr>
+            <a:r>
+              <a:t>Automated Risk Triage &amp; 7-Day Sleep Loss Forecaster</a:t>
             </a:r>
           </a:p>
         </p:txBody>
@@ -6719,8 +6794,8 @@
         </p:nvSpPr>
         <p:spPr>
           <a:xfrm>
-            <a:off x="822960" y="1691640"/>
-            <a:ext cx="10545775" cy="1417320"/>
+            <a:off x="822960" y="1600200"/>
+            <a:ext cx="10545775" cy="1463040"/>
           </a:xfrm>
           <a:prstGeom prst="roundRect">
             <a:avLst/>
@@ -6730,7 +6805,7 @@
           </a:solidFill>
           <a:ln w="12700">
             <a:solidFill>
-              <a:srgbClr val="CBD5E1"/>
+              <a:srgbClr val="94A3B8"/>
             </a:solidFill>
           </a:ln>
         </p:spPr>
@@ -6764,17 +6839,19 @@
         </p:nvSpPr>
         <p:spPr>
           <a:xfrm>
-            <a:off x="1051560" y="1920240"/>
-            <a:ext cx="822960" cy="868680"/>
+            <a:off x="1051560" y="1856232"/>
+            <a:ext cx="777240" cy="868680"/>
           </a:xfrm>
           <a:prstGeom prst="roundRect">
             <a:avLst/>
           </a:prstGeom>
           <a:solidFill>
-            <a:srgbClr val="2563EB"/>
-          </a:solidFill>
-          <a:ln>
-            <a:noFill/>
+            <a:srgbClr val="F1F5F9"/>
+          </a:solidFill>
+          <a:ln w="19050">
+            <a:solidFill>
+              <a:srgbClr val="1D4ED8"/>
+            </a:solidFill>
           </a:ln>
         </p:spPr>
         <p:style>
@@ -6798,9 +6875,9 @@
             <a:pPr algn="ctr">
               <a:defRPr sz="2000" b="1">
                 <a:solidFill>
-                  <a:srgbClr val="FFFFFF"/>
-                </a:solidFill>
-                <a:latin typeface="Calibri"/>
+                  <a:srgbClr val="1D4ED8"/>
+                </a:solidFill>
+                <a:latin typeface="Arial"/>
               </a:defRPr>
             </a:pPr>
             <a:r>
@@ -6817,8 +6894,8 @@
         </p:nvSpPr>
         <p:spPr>
           <a:xfrm>
-            <a:off x="2057400" y="1828800"/>
-            <a:ext cx="9144000" cy="1143000"/>
+            <a:off x="2057400" y="1737360"/>
+            <a:ext cx="9144000" cy="1188720"/>
           </a:xfrm>
           <a:prstGeom prst="rect">
             <a:avLst/>
@@ -6832,15 +6909,15 @@
           <a:lstStyle/>
           <a:p>
             <a:pPr>
-              <a:defRPr sz="1400" b="1">
+              <a:defRPr sz="1350" b="1">
                 <a:solidFill>
                   <a:srgbClr val="0F172A"/>
                 </a:solidFill>
-                <a:latin typeface="Calibri"/>
-              </a:defRPr>
-            </a:pPr>
-            <a:r>
-              <a:t>Rule-Based Clinical Triage Scoring Algorithm</a:t>
+                <a:latin typeface="Arial"/>
+              </a:defRPr>
+            </a:pPr>
+            <a:r>
+              <a:t>Automatic Red / Yellow / Green Tagging</a:t>
             </a:r>
           </a:p>
           <a:p>
@@ -6848,15 +6925,15 @@
               <a:spcBef>
                 <a:spcPts val="400"/>
               </a:spcBef>
-              <a:defRPr sz="1150">
-                <a:solidFill>
-                  <a:srgbClr val="334155"/>
-                </a:solidFill>
-                <a:latin typeface="Calibri"/>
-              </a:defRPr>
-            </a:pPr>
-            <a:r>
-              <a:t>Instantly evaluates inputs against medical thresholds to tag entries as High Risk (Red - immediate intervention), Medium Risk (Yellow), or Low Risk (Green - stable).</a:t>
+              <a:defRPr sz="1100">
+                <a:solidFill>
+                  <a:srgbClr val="1E293B"/>
+                </a:solidFill>
+                <a:latin typeface="Arial"/>
+              </a:defRPr>
+            </a:pPr>
+            <a:r>
+              <a:t>If sleep is under 5 hours or stress is 8 or above, the app immediately tags the soldier in RED (High Risk) so officers can help right away.</a:t>
             </a:r>
           </a:p>
         </p:txBody>
@@ -6869,8 +6946,8 @@
         </p:nvSpPr>
         <p:spPr>
           <a:xfrm>
-            <a:off x="822960" y="3291840"/>
-            <a:ext cx="10545775" cy="1417320"/>
+            <a:off x="822960" y="3246120"/>
+            <a:ext cx="10545775" cy="1463040"/>
           </a:xfrm>
           <a:prstGeom prst="roundRect">
             <a:avLst/>
@@ -6880,7 +6957,7 @@
           </a:solidFill>
           <a:ln w="12700">
             <a:solidFill>
-              <a:srgbClr val="CBD5E1"/>
+              <a:srgbClr val="94A3B8"/>
             </a:solidFill>
           </a:ln>
         </p:spPr>
@@ -6914,17 +6991,19 @@
         </p:nvSpPr>
         <p:spPr>
           <a:xfrm>
-            <a:off x="1051560" y="3520440"/>
-            <a:ext cx="822960" cy="868680"/>
+            <a:off x="1051560" y="3502152"/>
+            <a:ext cx="777240" cy="868680"/>
           </a:xfrm>
           <a:prstGeom prst="roundRect">
             <a:avLst/>
           </a:prstGeom>
           <a:solidFill>
-            <a:srgbClr val="0D9488"/>
-          </a:solidFill>
-          <a:ln>
-            <a:noFill/>
+            <a:srgbClr val="F1F5F9"/>
+          </a:solidFill>
+          <a:ln w="19050">
+            <a:solidFill>
+              <a:srgbClr val="0F766E"/>
+            </a:solidFill>
           </a:ln>
         </p:spPr>
         <p:style>
@@ -6948,9 +7027,9 @@
             <a:pPr algn="ctr">
               <a:defRPr sz="2000" b="1">
                 <a:solidFill>
-                  <a:srgbClr val="FFFFFF"/>
-                </a:solidFill>
-                <a:latin typeface="Calibri"/>
+                  <a:srgbClr val="0F766E"/>
+                </a:solidFill>
+                <a:latin typeface="Arial"/>
               </a:defRPr>
             </a:pPr>
             <a:r>
@@ -6967,8 +7046,8 @@
         </p:nvSpPr>
         <p:spPr>
           <a:xfrm>
-            <a:off x="2057400" y="3429000"/>
-            <a:ext cx="9144000" cy="1143000"/>
+            <a:off x="2057400" y="3383280"/>
+            <a:ext cx="9144000" cy="1188720"/>
           </a:xfrm>
           <a:prstGeom prst="rect">
             <a:avLst/>
@@ -6982,15 +7061,15 @@
           <a:lstStyle/>
           <a:p>
             <a:pPr>
-              <a:defRPr sz="1400" b="1">
+              <a:defRPr sz="1350" b="1">
                 <a:solidFill>
                   <a:srgbClr val="0F172A"/>
                 </a:solidFill>
-                <a:latin typeface="Calibri"/>
-              </a:defRPr>
-            </a:pPr>
-            <a:r>
-              <a:t>Cumulative 7-Day Fatigue &amp; Sleep Debt Forecaster</a:t>
+                <a:latin typeface="Arial"/>
+              </a:defRPr>
+            </a:pPr>
+            <a:r>
+              <a:t>7-Day Sleep Debt Calculation</a:t>
             </a:r>
           </a:p>
           <a:p>
@@ -6998,15 +7077,15 @@
               <a:spcBef>
                 <a:spcPts val="400"/>
               </a:spcBef>
-              <a:defRPr sz="1150">
-                <a:solidFill>
-                  <a:srgbClr val="334155"/>
-                </a:solidFill>
-                <a:latin typeface="Calibri"/>
-              </a:defRPr>
-            </a:pPr>
-            <a:r>
-              <a:t>Calculates cumulative sleep deficit from a 7-hour baseline to generate the Operational Strain Index (0-100%) and personalized recovery advisories.</a:t>
+              <a:defRPr sz="1100">
+                <a:solidFill>
+                  <a:srgbClr val="1E293B"/>
+                </a:solidFill>
+                <a:latin typeface="Arial"/>
+              </a:defRPr>
+            </a:pPr>
+            <a:r>
+              <a:t>App calculates total lost sleep compared to the 7-hour army baseline and creates a 0-100% Operational Fatigue Score.</a:t>
             </a:r>
           </a:p>
         </p:txBody>
@@ -7020,7 +7099,7 @@
         <p:spPr>
           <a:xfrm>
             <a:off x="822960" y="4892040"/>
-            <a:ext cx="10545775" cy="1417320"/>
+            <a:ext cx="10545775" cy="1463040"/>
           </a:xfrm>
           <a:prstGeom prst="roundRect">
             <a:avLst/>
@@ -7030,7 +7109,7 @@
           </a:solidFill>
           <a:ln w="12700">
             <a:solidFill>
-              <a:srgbClr val="CBD5E1"/>
+              <a:srgbClr val="94A3B8"/>
             </a:solidFill>
           </a:ln>
         </p:spPr>
@@ -7064,17 +7143,19 @@
         </p:nvSpPr>
         <p:spPr>
           <a:xfrm>
-            <a:off x="1051560" y="5120640"/>
-            <a:ext cx="822960" cy="868680"/>
+            <a:off x="1051560" y="5148072"/>
+            <a:ext cx="777240" cy="868680"/>
           </a:xfrm>
           <a:prstGeom prst="roundRect">
             <a:avLst/>
           </a:prstGeom>
           <a:solidFill>
-            <a:srgbClr val="0F172A"/>
-          </a:solidFill>
-          <a:ln>
-            <a:noFill/>
+            <a:srgbClr val="F1F5F9"/>
+          </a:solidFill>
+          <a:ln w="19050">
+            <a:solidFill>
+              <a:srgbClr val="0F172A"/>
+            </a:solidFill>
           </a:ln>
         </p:spPr>
         <p:style>
@@ -7098,9 +7179,9 @@
             <a:pPr algn="ctr">
               <a:defRPr sz="2000" b="1">
                 <a:solidFill>
-                  <a:srgbClr val="FFFFFF"/>
-                </a:solidFill>
-                <a:latin typeface="Calibri"/>
+                  <a:srgbClr val="0F172A"/>
+                </a:solidFill>
+                <a:latin typeface="Arial"/>
               </a:defRPr>
             </a:pPr>
             <a:r>
@@ -7118,7 +7199,7 @@
         <p:spPr>
           <a:xfrm>
             <a:off x="2057400" y="5029200"/>
-            <a:ext cx="9144000" cy="1143000"/>
+            <a:ext cx="9144000" cy="1188720"/>
           </a:xfrm>
           <a:prstGeom prst="rect">
             <a:avLst/>
@@ -7132,15 +7213,15 @@
           <a:lstStyle/>
           <a:p>
             <a:pPr>
-              <a:defRPr sz="1400" b="1">
+              <a:defRPr sz="1350" b="1">
                 <a:solidFill>
                   <a:srgbClr val="0F172A"/>
                 </a:solidFill>
-                <a:latin typeface="Calibri"/>
-              </a:defRPr>
-            </a:pPr>
-            <a:r>
-              <a:t>Proactive Burnout Prevention for Field Command</a:t>
+                <a:latin typeface="Arial"/>
+              </a:defRPr>
+            </a:pPr>
+            <a:r>
+              <a:t>Rest Alert to Prevent Duty Accidents</a:t>
             </a:r>
           </a:p>
           <a:p>
@@ -7148,15 +7229,15 @@
               <a:spcBef>
                 <a:spcPts val="400"/>
               </a:spcBef>
-              <a:defRPr sz="1150">
-                <a:solidFill>
-                  <a:srgbClr val="334155"/>
-                </a:solidFill>
-                <a:latin typeface="Calibri"/>
-              </a:defRPr>
-            </a:pPr>
-            <a:r>
-              <a:t>Alerts unit officers when soldier fatigue crosses safety thresholds (above 65%), preventing weapon-handling mishaps and guard duty vigilance failures.</a:t>
+              <a:defRPr sz="1100">
+                <a:solidFill>
+                  <a:srgbClr val="1E293B"/>
+                </a:solidFill>
+                <a:latin typeface="Arial"/>
+              </a:defRPr>
+            </a:pPr>
+            <a:r>
+              <a:t>If a soldier's fatigue score crosses 65%, the system immediately recommends mandatory rest to prevent weapon accidents and duty mistakes.</a:t>
             </a:r>
           </a:p>
         </p:txBody>
@@ -7169,7 +7250,7 @@
         </p:nvSpPr>
         <p:spPr>
           <a:xfrm>
-            <a:off x="822960" y="6400800"/>
+            <a:off x="822960" y="6446520"/>
             <a:ext cx="10515600" cy="320040"/>
           </a:xfrm>
           <a:prstGeom prst="rect">
@@ -7188,11 +7269,11 @@
                 <a:solidFill>
                   <a:srgbClr val="64748B"/>
                 </a:solidFill>
-                <a:latin typeface="Calibri"/>
-              </a:defRPr>
-            </a:pPr>
-            <a:r>
-              <a:t>APPS - AI Predictive Personnel Stress &amp; Welfare Monitoring Systems | Computer Science &amp; Business Systems</a:t>
+                <a:latin typeface="Arial"/>
+              </a:defRPr>
+            </a:pPr>
+            <a:r>
+              <a:t>APPS - Final Year Mini Project | DHARUN.M (CSBS) | Slide 6 of 10</a:t>
             </a:r>
           </a:p>
         </p:txBody>
@@ -7230,7 +7311,7 @@
             <a:avLst/>
           </a:prstGeom>
           <a:solidFill>
-            <a:srgbClr val="F8FAFC"/>
+            <a:srgbClr val="FFFFFF"/>
           </a:solidFill>
           <a:ln>
             <a:noFill/>
@@ -7266,18 +7347,18 @@
         </p:nvSpPr>
         <p:spPr>
           <a:xfrm>
-            <a:off x="822960" y="457200"/>
-            <a:ext cx="2926080" cy="320040"/>
+            <a:off x="822960" y="411480"/>
+            <a:ext cx="3200400" cy="320040"/>
           </a:xfrm>
           <a:prstGeom prst="roundRect">
             <a:avLst/>
           </a:prstGeom>
           <a:solidFill>
-            <a:srgbClr val="EFF6FF"/>
+            <a:srgbClr val="F1F5F9"/>
           </a:solidFill>
           <a:ln>
             <a:solidFill>
-              <a:srgbClr val="BFDBFE"/>
+              <a:srgbClr val="94A3B8"/>
             </a:solidFill>
           </a:ln>
         </p:spPr>
@@ -7302,13 +7383,13 @@
             <a:pPr algn="ctr">
               <a:defRPr sz="950" b="1">
                 <a:solidFill>
-                  <a:srgbClr val="2563EB"/>
-                </a:solidFill>
-                <a:latin typeface="Calibri"/>
-              </a:defRPr>
-            </a:pPr>
-            <a:r>
-              <a:t>SLIDE 07 | EMERGENCY RESPONSE</a:t>
+                  <a:srgbClr val="1D4ED8"/>
+                </a:solidFill>
+                <a:latin typeface="Arial"/>
+              </a:defRPr>
+            </a:pPr>
+            <a:r>
+              <a:t>SLIDE 07 | EMERGENCY TOOLS</a:t>
             </a:r>
           </a:p>
         </p:txBody>
@@ -7321,7 +7402,7 @@
         </p:nvSpPr>
         <p:spPr>
           <a:xfrm>
-            <a:off x="822960" y="822960"/>
+            <a:off x="822960" y="777240"/>
             <a:ext cx="10515600" cy="731520"/>
           </a:xfrm>
           <a:prstGeom prst="rect">
@@ -7336,15 +7417,15 @@
           <a:lstStyle/>
           <a:p>
             <a:pPr>
-              <a:defRPr sz="2200" b="1">
+              <a:defRPr sz="2100" b="1">
                 <a:solidFill>
                   <a:srgbClr val="0F172A"/>
                 </a:solidFill>
-                <a:latin typeface="Calibri"/>
-              </a:defRPr>
-            </a:pPr>
-            <a:r>
-              <a:t>Life-Saving Crisis SOS &amp; 4-7-8 Breathing Tool</a:t>
+                <a:latin typeface="Arial"/>
+              </a:defRPr>
+            </a:pPr>
+            <a:r>
+              <a:t>1-Click Crisis SOS &amp; 4-7-8 Breathing Calmer</a:t>
             </a:r>
           </a:p>
         </p:txBody>
@@ -7357,8 +7438,8 @@
         </p:nvSpPr>
         <p:spPr>
           <a:xfrm>
-            <a:off x="822960" y="1691640"/>
-            <a:ext cx="10545775" cy="1417320"/>
+            <a:off x="822960" y="1600200"/>
+            <a:ext cx="10545775" cy="1463040"/>
           </a:xfrm>
           <a:prstGeom prst="roundRect">
             <a:avLst/>
@@ -7368,7 +7449,7 @@
           </a:solidFill>
           <a:ln w="12700">
             <a:solidFill>
-              <a:srgbClr val="CBD5E1"/>
+              <a:srgbClr val="94A3B8"/>
             </a:solidFill>
           </a:ln>
         </p:spPr>
@@ -7402,17 +7483,19 @@
         </p:nvSpPr>
         <p:spPr>
           <a:xfrm>
-            <a:off x="1051560" y="1920240"/>
-            <a:ext cx="822960" cy="868680"/>
+            <a:off x="1051560" y="1856232"/>
+            <a:ext cx="777240" cy="868680"/>
           </a:xfrm>
           <a:prstGeom prst="roundRect">
             <a:avLst/>
           </a:prstGeom>
           <a:solidFill>
-            <a:srgbClr val="2563EB"/>
-          </a:solidFill>
-          <a:ln>
-            <a:noFill/>
+            <a:srgbClr val="F1F5F9"/>
+          </a:solidFill>
+          <a:ln w="19050">
+            <a:solidFill>
+              <a:srgbClr val="1D4ED8"/>
+            </a:solidFill>
           </a:ln>
         </p:spPr>
         <p:style>
@@ -7436,9 +7519,9 @@
             <a:pPr algn="ctr">
               <a:defRPr sz="2000" b="1">
                 <a:solidFill>
-                  <a:srgbClr val="FFFFFF"/>
-                </a:solidFill>
-                <a:latin typeface="Calibri"/>
+                  <a:srgbClr val="1D4ED8"/>
+                </a:solidFill>
+                <a:latin typeface="Arial"/>
               </a:defRPr>
             </a:pPr>
             <a:r>
@@ -7455,8 +7538,8 @@
         </p:nvSpPr>
         <p:spPr>
           <a:xfrm>
-            <a:off x="2057400" y="1828800"/>
-            <a:ext cx="9144000" cy="1143000"/>
+            <a:off x="2057400" y="1737360"/>
+            <a:ext cx="9144000" cy="1188720"/>
           </a:xfrm>
           <a:prstGeom prst="rect">
             <a:avLst/>
@@ -7470,15 +7553,15 @@
           <a:lstStyle/>
           <a:p>
             <a:pPr>
-              <a:defRPr sz="1400" b="1">
+              <a:defRPr sz="1350" b="1">
                 <a:solidFill>
                   <a:srgbClr val="0F172A"/>
                 </a:solidFill>
-                <a:latin typeface="Calibri"/>
-              </a:defRPr>
-            </a:pPr>
-            <a:r>
-              <a:t>1-Click Defense Crisis SOS Emergency Beacon</a:t>
+                <a:latin typeface="Arial"/>
+              </a:defRPr>
+            </a:pPr>
+            <a:r>
+              <a:t>1-Click Crisis SOS Button</a:t>
             </a:r>
           </a:p>
           <a:p>
@@ -7486,15 +7569,15 @@
               <a:spcBef>
                 <a:spcPts val="400"/>
               </a:spcBef>
-              <a:defRPr sz="1150">
-                <a:solidFill>
-                  <a:srgbClr val="334155"/>
-                </a:solidFill>
-                <a:latin typeface="Calibri"/>
-              </a:defRPr>
-            </a:pPr>
-            <a:r>
-              <a:t>Provides instant one-tap dialing to Army Emergency Helpline (1902) and National Tele-MANAS (14416) during severe psychological breakdown.</a:t>
+              <a:defRPr sz="1100">
+                <a:solidFill>
+                  <a:srgbClr val="1E293B"/>
+                </a:solidFill>
+                <a:latin typeface="Arial"/>
+              </a:defRPr>
+            </a:pPr>
+            <a:r>
+              <a:t>A prominent red SOS button allows soldiers in severe distress to immediately call the Army Helpline (1902) or Tele-MANAS (14416).</a:t>
             </a:r>
           </a:p>
         </p:txBody>
@@ -7507,8 +7590,8 @@
         </p:nvSpPr>
         <p:spPr>
           <a:xfrm>
-            <a:off x="822960" y="3291840"/>
-            <a:ext cx="10545775" cy="1417320"/>
+            <a:off x="822960" y="3246120"/>
+            <a:ext cx="10545775" cy="1463040"/>
           </a:xfrm>
           <a:prstGeom prst="roundRect">
             <a:avLst/>
@@ -7518,7 +7601,7 @@
           </a:solidFill>
           <a:ln w="12700">
             <a:solidFill>
-              <a:srgbClr val="CBD5E1"/>
+              <a:srgbClr val="94A3B8"/>
             </a:solidFill>
           </a:ln>
         </p:spPr>
@@ -7552,17 +7635,19 @@
         </p:nvSpPr>
         <p:spPr>
           <a:xfrm>
-            <a:off x="1051560" y="3520440"/>
-            <a:ext cx="822960" cy="868680"/>
+            <a:off x="1051560" y="3502152"/>
+            <a:ext cx="777240" cy="868680"/>
           </a:xfrm>
           <a:prstGeom prst="roundRect">
             <a:avLst/>
           </a:prstGeom>
           <a:solidFill>
-            <a:srgbClr val="0D9488"/>
-          </a:solidFill>
-          <a:ln>
-            <a:noFill/>
+            <a:srgbClr val="F1F5F9"/>
+          </a:solidFill>
+          <a:ln w="19050">
+            <a:solidFill>
+              <a:srgbClr val="0F766E"/>
+            </a:solidFill>
           </a:ln>
         </p:spPr>
         <p:style>
@@ -7586,9 +7671,9 @@
             <a:pPr algn="ctr">
               <a:defRPr sz="2000" b="1">
                 <a:solidFill>
-                  <a:srgbClr val="FFFFFF"/>
-                </a:solidFill>
-                <a:latin typeface="Calibri"/>
+                  <a:srgbClr val="0F766E"/>
+                </a:solidFill>
+                <a:latin typeface="Arial"/>
               </a:defRPr>
             </a:pPr>
             <a:r>
@@ -7605,8 +7690,8 @@
         </p:nvSpPr>
         <p:spPr>
           <a:xfrm>
-            <a:off x="2057400" y="3429000"/>
-            <a:ext cx="9144000" cy="1143000"/>
+            <a:off x="2057400" y="3383280"/>
+            <a:ext cx="9144000" cy="1188720"/>
           </a:xfrm>
           <a:prstGeom prst="rect">
             <a:avLst/>
@@ -7620,15 +7705,15 @@
           <a:lstStyle/>
           <a:p>
             <a:pPr>
-              <a:defRPr sz="1400" b="1">
+              <a:defRPr sz="1350" b="1">
                 <a:solidFill>
                   <a:srgbClr val="0F172A"/>
                 </a:solidFill>
-                <a:latin typeface="Calibri"/>
-              </a:defRPr>
-            </a:pPr>
-            <a:r>
-              <a:t>Command Dashboard Crimson Red Alert Intercept</a:t>
+                <a:latin typeface="Arial"/>
+              </a:defRPr>
+            </a:pPr>
+            <a:r>
+              <a:t>Flashing Red Alert for Officers</a:t>
             </a:r>
           </a:p>
           <a:p>
@@ -7636,15 +7721,15 @@
               <a:spcBef>
                 <a:spcPts val="400"/>
               </a:spcBef>
-              <a:defRPr sz="1150">
-                <a:solidFill>
-                  <a:srgbClr val="334155"/>
-                </a:solidFill>
-                <a:latin typeface="Calibri"/>
-              </a:defRPr>
-            </a:pPr>
-            <a:r>
-              <a:t>Triggering the SOS beacon immediately broadcasts high-priority pulsing red alert banners across officer and headquarters screens for rapid intervention.</a:t>
+              <a:defRPr sz="1100">
+                <a:solidFill>
+                  <a:srgbClr val="1E293B"/>
+                </a:solidFill>
+                <a:latin typeface="Arial"/>
+              </a:defRPr>
+            </a:pPr>
+            <a:r>
+              <a:t>When a soldier taps the SOS button, a flashing crimson red alert banner immediately pops up on the commanding officer's computer screen.</a:t>
             </a:r>
           </a:p>
         </p:txBody>
@@ -7658,7 +7743,7 @@
         <p:spPr>
           <a:xfrm>
             <a:off x="822960" y="4892040"/>
-            <a:ext cx="10545775" cy="1417320"/>
+            <a:ext cx="10545775" cy="1463040"/>
           </a:xfrm>
           <a:prstGeom prst="roundRect">
             <a:avLst/>
@@ -7668,7 +7753,7 @@
           </a:solidFill>
           <a:ln w="12700">
             <a:solidFill>
-              <a:srgbClr val="CBD5E1"/>
+              <a:srgbClr val="94A3B8"/>
             </a:solidFill>
           </a:ln>
         </p:spPr>
@@ -7702,17 +7787,19 @@
         </p:nvSpPr>
         <p:spPr>
           <a:xfrm>
-            <a:off x="1051560" y="5120640"/>
-            <a:ext cx="822960" cy="868680"/>
+            <a:off x="1051560" y="5148072"/>
+            <a:ext cx="777240" cy="868680"/>
           </a:xfrm>
           <a:prstGeom prst="roundRect">
             <a:avLst/>
           </a:prstGeom>
           <a:solidFill>
-            <a:srgbClr val="0F172A"/>
-          </a:solidFill>
-          <a:ln>
-            <a:noFill/>
+            <a:srgbClr val="F1F5F9"/>
+          </a:solidFill>
+          <a:ln w="19050">
+            <a:solidFill>
+              <a:srgbClr val="0F172A"/>
+            </a:solidFill>
           </a:ln>
         </p:spPr>
         <p:style>
@@ -7736,9 +7823,9 @@
             <a:pPr algn="ctr">
               <a:defRPr sz="2000" b="1">
                 <a:solidFill>
-                  <a:srgbClr val="FFFFFF"/>
-                </a:solidFill>
-                <a:latin typeface="Calibri"/>
+                  <a:srgbClr val="0F172A"/>
+                </a:solidFill>
+                <a:latin typeface="Arial"/>
               </a:defRPr>
             </a:pPr>
             <a:r>
@@ -7756,7 +7843,7 @@
         <p:spPr>
           <a:xfrm>
             <a:off x="2057400" y="5029200"/>
-            <a:ext cx="9144000" cy="1143000"/>
+            <a:ext cx="9144000" cy="1188720"/>
           </a:xfrm>
           <a:prstGeom prst="rect">
             <a:avLst/>
@@ -7770,15 +7857,15 @@
           <a:lstStyle/>
           <a:p>
             <a:pPr>
-              <a:defRPr sz="1400" b="1">
+              <a:defRPr sz="1350" b="1">
                 <a:solidFill>
                   <a:srgbClr val="0F172A"/>
                 </a:solidFill>
-                <a:latin typeface="Calibri"/>
-              </a:defRPr>
-            </a:pPr>
-            <a:r>
-              <a:t>Tactical 4-7-8 Breathing &amp; Panic De-Escalation Engine</a:t>
+                <a:latin typeface="Arial"/>
+              </a:defRPr>
+            </a:pPr>
+            <a:r>
+              <a:t>Tactical 4-7-8 Breathing Stabilizer</a:t>
             </a:r>
           </a:p>
           <a:p>
@@ -7786,15 +7873,15 @@
               <a:spcBef>
                 <a:spcPts val="400"/>
               </a:spcBef>
-              <a:defRPr sz="1150">
-                <a:solidFill>
-                  <a:srgbClr val="334155"/>
-                </a:solidFill>
-                <a:latin typeface="Calibri"/>
-              </a:defRPr>
-            </a:pPr>
-            <a:r>
-              <a:t>Interactive animated guide (4s Inhale, 7s Hold, 8s Exhale) activating the parasympathetic nervous system to quickly lower elevated heart rate and anxiety.</a:t>
+              <a:defRPr sz="1100">
+                <a:solidFill>
+                  <a:srgbClr val="1E293B"/>
+                </a:solidFill>
+                <a:latin typeface="Arial"/>
+              </a:defRPr>
+            </a:pPr>
+            <a:r>
+              <a:t>An animated circle guides the soldier: Inhale for 4s, Hold for 7s, and Exhale for 8s to quickly lower elevated heart rate and panic.</a:t>
             </a:r>
           </a:p>
         </p:txBody>
@@ -7807,7 +7894,7 @@
         </p:nvSpPr>
         <p:spPr>
           <a:xfrm>
-            <a:off x="822960" y="6400800"/>
+            <a:off x="822960" y="6446520"/>
             <a:ext cx="10515600" cy="320040"/>
           </a:xfrm>
           <a:prstGeom prst="rect">
@@ -7826,11 +7913,11 @@
                 <a:solidFill>
                   <a:srgbClr val="64748B"/>
                 </a:solidFill>
-                <a:latin typeface="Calibri"/>
-              </a:defRPr>
-            </a:pPr>
-            <a:r>
-              <a:t>APPS - AI Predictive Personnel Stress &amp; Welfare Monitoring Systems | Computer Science &amp; Business Systems</a:t>
+                <a:latin typeface="Arial"/>
+              </a:defRPr>
+            </a:pPr>
+            <a:r>
+              <a:t>APPS - Final Year Mini Project | DHARUN.M (CSBS) | Slide 7 of 10</a:t>
             </a:r>
           </a:p>
         </p:txBody>
@@ -7868,7 +7955,7 @@
             <a:avLst/>
           </a:prstGeom>
           <a:solidFill>
-            <a:srgbClr val="F8FAFC"/>
+            <a:srgbClr val="FFFFFF"/>
           </a:solidFill>
           <a:ln>
             <a:noFill/>
@@ -7904,18 +7991,18 @@
         </p:nvSpPr>
         <p:spPr>
           <a:xfrm>
-            <a:off x="822960" y="457200"/>
-            <a:ext cx="2926080" cy="320040"/>
+            <a:off x="822960" y="411480"/>
+            <a:ext cx="3200400" cy="320040"/>
           </a:xfrm>
           <a:prstGeom prst="roundRect">
             <a:avLst/>
           </a:prstGeom>
           <a:solidFill>
-            <a:srgbClr val="EFF6FF"/>
+            <a:srgbClr val="F1F5F9"/>
           </a:solidFill>
           <a:ln>
             <a:solidFill>
-              <a:srgbClr val="BFDBFE"/>
+              <a:srgbClr val="94A3B8"/>
             </a:solidFill>
           </a:ln>
         </p:spPr>
@@ -7940,9 +8027,9 @@
             <a:pPr algn="ctr">
               <a:defRPr sz="950" b="1">
                 <a:solidFill>
-                  <a:srgbClr val="2563EB"/>
-                </a:solidFill>
-                <a:latin typeface="Calibri"/>
+                  <a:srgbClr val="1D4ED8"/>
+                </a:solidFill>
+                <a:latin typeface="Arial"/>
               </a:defRPr>
             </a:pPr>
             <a:r>
@@ -7959,7 +8046,7 @@
         </p:nvSpPr>
         <p:spPr>
           <a:xfrm>
-            <a:off x="822960" y="822960"/>
+            <a:off x="822960" y="777240"/>
             <a:ext cx="10515600" cy="731520"/>
           </a:xfrm>
           <a:prstGeom prst="rect">
@@ -7974,15 +8061,15 @@
           <a:lstStyle/>
           <a:p>
             <a:pPr>
-              <a:defRPr sz="2200" b="1">
+              <a:defRPr sz="2100" b="1">
                 <a:solidFill>
                   <a:srgbClr val="0F172A"/>
                 </a:solidFill>
-                <a:latin typeface="Calibri"/>
-              </a:defRPr>
-            </a:pPr>
-            <a:r>
-              <a:t>Welfare Officer Supervision &amp; Senior Admin Controls</a:t>
+                <a:latin typeface="Arial"/>
+              </a:defRPr>
+            </a:pPr>
+            <a:r>
+              <a:t>Supervision Tools for Welfare Officers &amp; Admins</a:t>
             </a:r>
           </a:p>
         </p:txBody>
@@ -7995,8 +8082,8 @@
         </p:nvSpPr>
         <p:spPr>
           <a:xfrm>
-            <a:off x="822960" y="1691640"/>
-            <a:ext cx="10545775" cy="1417320"/>
+            <a:off x="822960" y="1600200"/>
+            <a:ext cx="10545775" cy="1463040"/>
           </a:xfrm>
           <a:prstGeom prst="roundRect">
             <a:avLst/>
@@ -8006,7 +8093,7 @@
           </a:solidFill>
           <a:ln w="12700">
             <a:solidFill>
-              <a:srgbClr val="CBD5E1"/>
+              <a:srgbClr val="94A3B8"/>
             </a:solidFill>
           </a:ln>
         </p:spPr>
@@ -8040,17 +8127,19 @@
         </p:nvSpPr>
         <p:spPr>
           <a:xfrm>
-            <a:off x="1051560" y="1920240"/>
-            <a:ext cx="822960" cy="868680"/>
+            <a:off x="1051560" y="1856232"/>
+            <a:ext cx="777240" cy="868680"/>
           </a:xfrm>
           <a:prstGeom prst="roundRect">
             <a:avLst/>
           </a:prstGeom>
           <a:solidFill>
-            <a:srgbClr val="2563EB"/>
-          </a:solidFill>
-          <a:ln>
-            <a:noFill/>
+            <a:srgbClr val="F1F5F9"/>
+          </a:solidFill>
+          <a:ln w="19050">
+            <a:solidFill>
+              <a:srgbClr val="1D4ED8"/>
+            </a:solidFill>
           </a:ln>
         </p:spPr>
         <p:style>
@@ -8074,9 +8163,9 @@
             <a:pPr algn="ctr">
               <a:defRPr sz="2000" b="1">
                 <a:solidFill>
-                  <a:srgbClr val="FFFFFF"/>
-                </a:solidFill>
-                <a:latin typeface="Calibri"/>
+                  <a:srgbClr val="1D4ED8"/>
+                </a:solidFill>
+                <a:latin typeface="Arial"/>
               </a:defRPr>
             </a:pPr>
             <a:r>
@@ -8093,8 +8182,8 @@
         </p:nvSpPr>
         <p:spPr>
           <a:xfrm>
-            <a:off x="2057400" y="1828800"/>
-            <a:ext cx="9144000" cy="1143000"/>
+            <a:off x="2057400" y="1737360"/>
+            <a:ext cx="9144000" cy="1188720"/>
           </a:xfrm>
           <a:prstGeom prst="rect">
             <a:avLst/>
@@ -8108,15 +8197,15 @@
           <a:lstStyle/>
           <a:p>
             <a:pPr>
-              <a:defRPr sz="1400" b="1">
+              <a:defRPr sz="1350" b="1">
                 <a:solidFill>
                   <a:srgbClr val="0F172A"/>
                 </a:solidFill>
-                <a:latin typeface="Calibri"/>
-              </a:defRPr>
-            </a:pPr>
-            <a:r>
-              <a:t>Live Personnel Monitoring Roster &amp; Search Filters</a:t>
+                <a:latin typeface="Arial"/>
+              </a:defRPr>
+            </a:pPr>
+            <a:r>
+              <a:t>Live Soldier Roster with Risk Filters</a:t>
             </a:r>
           </a:p>
           <a:p>
@@ -8124,15 +8213,15 @@
               <a:spcBef>
                 <a:spcPts val="400"/>
               </a:spcBef>
-              <a:defRPr sz="1150">
-                <a:solidFill>
-                  <a:srgbClr val="334155"/>
-                </a:solidFill>
-                <a:latin typeface="Calibri"/>
-              </a:defRPr>
-            </a:pPr>
-            <a:r>
-              <a:t>Enables Welfare Officers to view all squad members, filter by risk level, and immediately isolate soldiers requiring urgent clinical attention.</a:t>
+              <a:defRPr sz="1100">
+                <a:solidFill>
+                  <a:srgbClr val="1E293B"/>
+                </a:solidFill>
+                <a:latin typeface="Arial"/>
+              </a:defRPr>
+            </a:pPr>
+            <a:r>
+              <a:t>Welfare Officers can view all soldiers in their unit, filter by Red, Yellow, or Green, and immediately help soldiers in danger.</a:t>
             </a:r>
           </a:p>
         </p:txBody>
@@ -8145,8 +8234,8 @@
         </p:nvSpPr>
         <p:spPr>
           <a:xfrm>
-            <a:off x="822960" y="3291840"/>
-            <a:ext cx="10545775" cy="1417320"/>
+            <a:off x="822960" y="3246120"/>
+            <a:ext cx="10545775" cy="1463040"/>
           </a:xfrm>
           <a:prstGeom prst="roundRect">
             <a:avLst/>
@@ -8156,7 +8245,7 @@
           </a:solidFill>
           <a:ln w="12700">
             <a:solidFill>
-              <a:srgbClr val="CBD5E1"/>
+              <a:srgbClr val="94A3B8"/>
             </a:solidFill>
           </a:ln>
         </p:spPr>
@@ -8190,17 +8279,19 @@
         </p:nvSpPr>
         <p:spPr>
           <a:xfrm>
-            <a:off x="1051560" y="3520440"/>
-            <a:ext cx="822960" cy="868680"/>
+            <a:off x="1051560" y="3502152"/>
+            <a:ext cx="777240" cy="868680"/>
           </a:xfrm>
           <a:prstGeom prst="roundRect">
             <a:avLst/>
           </a:prstGeom>
           <a:solidFill>
-            <a:srgbClr val="0D9488"/>
-          </a:solidFill>
-          <a:ln>
-            <a:noFill/>
+            <a:srgbClr val="F1F5F9"/>
+          </a:solidFill>
+          <a:ln w="19050">
+            <a:solidFill>
+              <a:srgbClr val="0F766E"/>
+            </a:solidFill>
           </a:ln>
         </p:spPr>
         <p:style>
@@ -8224,9 +8315,9 @@
             <a:pPr algn="ctr">
               <a:defRPr sz="2000" b="1">
                 <a:solidFill>
-                  <a:srgbClr val="FFFFFF"/>
-                </a:solidFill>
-                <a:latin typeface="Calibri"/>
+                  <a:srgbClr val="0F766E"/>
+                </a:solidFill>
+                <a:latin typeface="Arial"/>
               </a:defRPr>
             </a:pPr>
             <a:r>
@@ -8243,8 +8334,8 @@
         </p:nvSpPr>
         <p:spPr>
           <a:xfrm>
-            <a:off x="2057400" y="3429000"/>
-            <a:ext cx="9144000" cy="1143000"/>
+            <a:off x="2057400" y="3383280"/>
+            <a:ext cx="9144000" cy="1188720"/>
           </a:xfrm>
           <a:prstGeom prst="rect">
             <a:avLst/>
@@ -8258,15 +8349,15 @@
           <a:lstStyle/>
           <a:p>
             <a:pPr>
-              <a:defRPr sz="1400" b="1">
+              <a:defRPr sz="1350" b="1">
                 <a:solidFill>
                   <a:srgbClr val="0F172A"/>
                 </a:solidFill>
-                <a:latin typeface="Calibri"/>
-              </a:defRPr>
-            </a:pPr>
-            <a:r>
-              <a:t>Confidential Clinical Counseling Notes Engine</a:t>
+                <a:latin typeface="Arial"/>
+              </a:defRPr>
+            </a:pPr>
+            <a:r>
+              <a:t>Confidential Counseling Diary</a:t>
             </a:r>
           </a:p>
           <a:p>
@@ -8274,15 +8365,15 @@
               <a:spcBef>
                 <a:spcPts val="400"/>
               </a:spcBef>
-              <a:defRPr sz="1150">
-                <a:solidFill>
-                  <a:srgbClr val="334155"/>
-                </a:solidFill>
-                <a:latin typeface="Calibri"/>
-              </a:defRPr>
-            </a:pPr>
-            <a:r>
-              <a:t>Provides structured documentation for officer counseling sessions, tracking clinical observations, follow-up flags, and review schedules securely.</a:t>
+              <a:defRPr sz="1100">
+                <a:solidFill>
+                  <a:srgbClr val="1E293B"/>
+                </a:solidFill>
+                <a:latin typeface="Arial"/>
+              </a:defRPr>
+            </a:pPr>
+            <a:r>
+              <a:t>Officers can record private clinical counseling notes, save action steps, and schedule follow-up dates securely in the database.</a:t>
             </a:r>
           </a:p>
         </p:txBody>
@@ -8296,7 +8387,7 @@
         <p:spPr>
           <a:xfrm>
             <a:off x="822960" y="4892040"/>
-            <a:ext cx="10545775" cy="1417320"/>
+            <a:ext cx="10545775" cy="1463040"/>
           </a:xfrm>
           <a:prstGeom prst="roundRect">
             <a:avLst/>
@@ -8306,7 +8397,7 @@
           </a:solidFill>
           <a:ln w="12700">
             <a:solidFill>
-              <a:srgbClr val="CBD5E1"/>
+              <a:srgbClr val="94A3B8"/>
             </a:solidFill>
           </a:ln>
         </p:spPr>
@@ -8340,17 +8431,19 @@
         </p:nvSpPr>
         <p:spPr>
           <a:xfrm>
-            <a:off x="1051560" y="5120640"/>
-            <a:ext cx="822960" cy="868680"/>
+            <a:off x="1051560" y="5148072"/>
+            <a:ext cx="777240" cy="868680"/>
           </a:xfrm>
           <a:prstGeom prst="roundRect">
             <a:avLst/>
           </a:prstGeom>
           <a:solidFill>
-            <a:srgbClr val="0F172A"/>
-          </a:solidFill>
-          <a:ln>
-            <a:noFill/>
+            <a:srgbClr val="F1F5F9"/>
+          </a:solidFill>
+          <a:ln w="19050">
+            <a:solidFill>
+              <a:srgbClr val="0F172A"/>
+            </a:solidFill>
           </a:ln>
         </p:spPr>
         <p:style>
@@ -8374,9 +8467,9 @@
             <a:pPr algn="ctr">
               <a:defRPr sz="2000" b="1">
                 <a:solidFill>
-                  <a:srgbClr val="FFFFFF"/>
-                </a:solidFill>
-                <a:latin typeface="Calibri"/>
+                  <a:srgbClr val="0F172A"/>
+                </a:solidFill>
+                <a:latin typeface="Arial"/>
               </a:defRPr>
             </a:pPr>
             <a:r>
@@ -8394,7 +8487,7 @@
         <p:spPr>
           <a:xfrm>
             <a:off x="2057400" y="5029200"/>
-            <a:ext cx="9144000" cy="1143000"/>
+            <a:ext cx="9144000" cy="1188720"/>
           </a:xfrm>
           <a:prstGeom prst="rect">
             <a:avLst/>
@@ -8408,15 +8501,15 @@
           <a:lstStyle/>
           <a:p>
             <a:pPr>
-              <a:defRPr sz="1400" b="1">
+              <a:defRPr sz="1350" b="1">
                 <a:solidFill>
                   <a:srgbClr val="0F172A"/>
                 </a:solidFill>
-                <a:latin typeface="Calibri"/>
-              </a:defRPr>
-            </a:pPr>
-            <a:r>
-              <a:t>Dynamic Command Master PIN &amp; Senior HQ Analytics</a:t>
+                <a:latin typeface="Arial"/>
+              </a:defRPr>
+            </a:pPr>
+            <a:r>
+              <a:t>Command Master PIN &amp; Army Statistics</a:t>
             </a:r>
           </a:p>
           <a:p>
@@ -8424,15 +8517,15 @@
               <a:spcBef>
                 <a:spcPts val="400"/>
               </a:spcBef>
-              <a:defRPr sz="1150">
-                <a:solidFill>
-                  <a:srgbClr val="334155"/>
-                </a:solidFill>
-                <a:latin typeface="Calibri"/>
-              </a:defRPr>
-            </a:pPr>
-            <a:r>
-              <a:t>Senior Admins monitor army-wide risk distributions, review immutable activity audit trails, and rotate the 4-digit Master PIN in real-time.</a:t>
+              <a:defRPr sz="1100">
+                <a:solidFill>
+                  <a:srgbClr val="1E293B"/>
+                </a:solidFill>
+                <a:latin typeface="Arial"/>
+              </a:defRPr>
+            </a:pPr>
+            <a:r>
+              <a:t>Senior Admins can view army-wide risk charts, check tamper-proof activity logs, and change the 4-digit signup security PIN anytime.</a:t>
             </a:r>
           </a:p>
         </p:txBody>
@@ -8445,7 +8538,7 @@
         </p:nvSpPr>
         <p:spPr>
           <a:xfrm>
-            <a:off x="822960" y="6400800"/>
+            <a:off x="822960" y="6446520"/>
             <a:ext cx="10515600" cy="320040"/>
           </a:xfrm>
           <a:prstGeom prst="rect">
@@ -8464,11 +8557,11 @@
                 <a:solidFill>
                   <a:srgbClr val="64748B"/>
                 </a:solidFill>
-                <a:latin typeface="Calibri"/>
-              </a:defRPr>
-            </a:pPr>
-            <a:r>
-              <a:t>APPS - AI Predictive Personnel Stress &amp; Welfare Monitoring Systems | Computer Science &amp; Business Systems</a:t>
+                <a:latin typeface="Arial"/>
+              </a:defRPr>
+            </a:pPr>
+            <a:r>
+              <a:t>APPS - Final Year Mini Project | DHARUN.M (CSBS) | Slide 8 of 10</a:t>
             </a:r>
           </a:p>
         </p:txBody>
@@ -8506,7 +8599,7 @@
             <a:avLst/>
           </a:prstGeom>
           <a:solidFill>
-            <a:srgbClr val="F8FAFC"/>
+            <a:srgbClr val="FFFFFF"/>
           </a:solidFill>
           <a:ln>
             <a:noFill/>
@@ -8542,18 +8635,18 @@
         </p:nvSpPr>
         <p:spPr>
           <a:xfrm>
-            <a:off x="822960" y="457200"/>
-            <a:ext cx="2926080" cy="320040"/>
+            <a:off x="822960" y="411480"/>
+            <a:ext cx="3200400" cy="320040"/>
           </a:xfrm>
           <a:prstGeom prst="roundRect">
             <a:avLst/>
           </a:prstGeom>
           <a:solidFill>
-            <a:srgbClr val="EFF6FF"/>
+            <a:srgbClr val="F1F5F9"/>
           </a:solidFill>
           <a:ln>
             <a:solidFill>
-              <a:srgbClr val="BFDBFE"/>
+              <a:srgbClr val="94A3B8"/>
             </a:solidFill>
           </a:ln>
         </p:spPr>
@@ -8578,13 +8671,13 @@
             <a:pPr algn="ctr">
               <a:defRPr sz="950" b="1">
                 <a:solidFill>
-                  <a:srgbClr val="2563EB"/>
-                </a:solidFill>
-                <a:latin typeface="Calibri"/>
-              </a:defRPr>
-            </a:pPr>
-            <a:r>
-              <a:t>SLIDE 09 | TECHNOLOGY &amp; SECURITY</a:t>
+                  <a:srgbClr val="1D4ED8"/>
+                </a:solidFill>
+                <a:latin typeface="Arial"/>
+              </a:defRPr>
+            </a:pPr>
+            <a:r>
+              <a:t>SLIDE 09 | TECH STACK &amp; SECURITY</a:t>
             </a:r>
           </a:p>
         </p:txBody>
@@ -8597,7 +8690,7 @@
         </p:nvSpPr>
         <p:spPr>
           <a:xfrm>
-            <a:off x="822960" y="822960"/>
+            <a:off x="822960" y="777240"/>
             <a:ext cx="10515600" cy="731520"/>
           </a:xfrm>
           <a:prstGeom prst="rect">
@@ -8612,15 +8705,15 @@
           <a:lstStyle/>
           <a:p>
             <a:pPr>
-              <a:defRPr sz="2200" b="1">
+              <a:defRPr sz="2100" b="1">
                 <a:solidFill>
                   <a:srgbClr val="0F172A"/>
                 </a:solidFill>
-                <a:latin typeface="Calibri"/>
-              </a:defRPr>
-            </a:pPr>
-            <a:r>
-              <a:t>Robust Tech Stack, Encryption &amp; Vernacular Support</a:t>
+                <a:latin typeface="Arial"/>
+              </a:defRPr>
+            </a:pPr>
+            <a:r>
+              <a:t>Tools Used &amp; Safety Mechanisms</a:t>
             </a:r>
           </a:p>
         </p:txBody>
@@ -8633,8 +8726,8 @@
         </p:nvSpPr>
         <p:spPr>
           <a:xfrm>
-            <a:off x="822960" y="1691640"/>
-            <a:ext cx="10545775" cy="1417320"/>
+            <a:off x="822960" y="1600200"/>
+            <a:ext cx="10545775" cy="1463040"/>
           </a:xfrm>
           <a:prstGeom prst="roundRect">
             <a:avLst/>
@@ -8644,7 +8737,7 @@
           </a:solidFill>
           <a:ln w="12700">
             <a:solidFill>
-              <a:srgbClr val="CBD5E1"/>
+              <a:srgbClr val="94A3B8"/>
             </a:solidFill>
           </a:ln>
         </p:spPr>
@@ -8678,17 +8771,19 @@
         </p:nvSpPr>
         <p:spPr>
           <a:xfrm>
-            <a:off x="1051560" y="1920240"/>
-            <a:ext cx="822960" cy="868680"/>
+            <a:off x="1051560" y="1856232"/>
+            <a:ext cx="777240" cy="868680"/>
           </a:xfrm>
           <a:prstGeom prst="roundRect">
             <a:avLst/>
           </a:prstGeom>
           <a:solidFill>
-            <a:srgbClr val="2563EB"/>
-          </a:solidFill>
-          <a:ln>
-            <a:noFill/>
+            <a:srgbClr val="F1F5F9"/>
+          </a:solidFill>
+          <a:ln w="19050">
+            <a:solidFill>
+              <a:srgbClr val="1D4ED8"/>
+            </a:solidFill>
           </a:ln>
         </p:spPr>
         <p:style>
@@ -8712,9 +8807,9 @@
             <a:pPr algn="ctr">
               <a:defRPr sz="2000" b="1">
                 <a:solidFill>
-                  <a:srgbClr val="FFFFFF"/>
-                </a:solidFill>
-                <a:latin typeface="Calibri"/>
+                  <a:srgbClr val="1D4ED8"/>
+                </a:solidFill>
+                <a:latin typeface="Arial"/>
               </a:defRPr>
             </a:pPr>
             <a:r>
@@ -8731,8 +8826,8 @@
         </p:nvSpPr>
         <p:spPr>
           <a:xfrm>
-            <a:off x="2057400" y="1828800"/>
-            <a:ext cx="9144000" cy="1143000"/>
+            <a:off x="2057400" y="1737360"/>
+            <a:ext cx="9144000" cy="1188720"/>
           </a:xfrm>
           <a:prstGeom prst="rect">
             <a:avLst/>
@@ -8746,15 +8841,15 @@
           <a:lstStyle/>
           <a:p>
             <a:pPr>
-              <a:defRPr sz="1400" b="1">
+              <a:defRPr sz="1350" b="1">
                 <a:solidFill>
                   <a:srgbClr val="0F172A"/>
                 </a:solidFill>
-                <a:latin typeface="Calibri"/>
-              </a:defRPr>
-            </a:pPr>
-            <a:r>
-              <a:t>Full-Stack Development Framework</a:t>
+                <a:latin typeface="Arial"/>
+              </a:defRPr>
+            </a:pPr>
+            <a:r>
+              <a:t>Reliable Modern Full-Stack</a:t>
             </a:r>
           </a:p>
           <a:p>
@@ -8762,15 +8857,15 @@
               <a:spcBef>
                 <a:spcPts val="400"/>
               </a:spcBef>
-              <a:defRPr sz="1150">
-                <a:solidFill>
-                  <a:srgbClr val="334155"/>
-                </a:solidFill>
-                <a:latin typeface="Calibri"/>
-              </a:defRPr>
-            </a:pPr>
-            <a:r>
-              <a:t>Engineered using Python Flask micro-framework, SQLite3 database, private Vercel Blob cloud storage, ReportLab PDF generators, and Vanilla CSS3/JS.</a:t>
+              <a:defRPr sz="1100">
+                <a:solidFill>
+                  <a:srgbClr val="1E293B"/>
+                </a:solidFill>
+                <a:latin typeface="Arial"/>
+              </a:defRPr>
+            </a:pPr>
+            <a:r>
+              <a:t>Built using Python Flask, SQLite database, Vercel Cloud Serverless platform, ReportLab for PDF exports, and Vanilla HTML/CSS/JS.</a:t>
             </a:r>
           </a:p>
         </p:txBody>
@@ -8783,8 +8878,8 @@
         </p:nvSpPr>
         <p:spPr>
           <a:xfrm>
-            <a:off x="822960" y="3291840"/>
-            <a:ext cx="10545775" cy="1417320"/>
+            <a:off x="822960" y="3246120"/>
+            <a:ext cx="10545775" cy="1463040"/>
           </a:xfrm>
           <a:prstGeom prst="roundRect">
             <a:avLst/>
@@ -8794,7 +8889,7 @@
           </a:solidFill>
           <a:ln w="12700">
             <a:solidFill>
-              <a:srgbClr val="CBD5E1"/>
+              <a:srgbClr val="94A3B8"/>
             </a:solidFill>
           </a:ln>
         </p:spPr>
@@ -8828,17 +8923,19 @@
         </p:nvSpPr>
         <p:spPr>
           <a:xfrm>
-            <a:off x="1051560" y="3520440"/>
-            <a:ext cx="822960" cy="868680"/>
+            <a:off x="1051560" y="3502152"/>
+            <a:ext cx="777240" cy="868680"/>
           </a:xfrm>
           <a:prstGeom prst="roundRect">
             <a:avLst/>
           </a:prstGeom>
           <a:solidFill>
-            <a:srgbClr val="0D9488"/>
-          </a:solidFill>
-          <a:ln>
-            <a:noFill/>
+            <a:srgbClr val="F1F5F9"/>
+          </a:solidFill>
+          <a:ln w="19050">
+            <a:solidFill>
+              <a:srgbClr val="0F766E"/>
+            </a:solidFill>
           </a:ln>
         </p:spPr>
         <p:style>
@@ -8862,9 +8959,9 @@
             <a:pPr algn="ctr">
               <a:defRPr sz="2000" b="1">
                 <a:solidFill>
-                  <a:srgbClr val="FFFFFF"/>
-                </a:solidFill>
-                <a:latin typeface="Calibri"/>
+                  <a:srgbClr val="0F766E"/>
+                </a:solidFill>
+                <a:latin typeface="Arial"/>
               </a:defRPr>
             </a:pPr>
             <a:r>
@@ -8881,8 +8978,8 @@
         </p:nvSpPr>
         <p:spPr>
           <a:xfrm>
-            <a:off x="2057400" y="3429000"/>
-            <a:ext cx="9144000" cy="1143000"/>
+            <a:off x="2057400" y="3383280"/>
+            <a:ext cx="9144000" cy="1188720"/>
           </a:xfrm>
           <a:prstGeom prst="rect">
             <a:avLst/>
@@ -8896,15 +8993,15 @@
           <a:lstStyle/>
           <a:p>
             <a:pPr>
-              <a:defRPr sz="1400" b="1">
+              <a:defRPr sz="1350" b="1">
                 <a:solidFill>
                   <a:srgbClr val="0F172A"/>
                 </a:solidFill>
-                <a:latin typeface="Calibri"/>
-              </a:defRPr>
-            </a:pPr>
-            <a:r>
-              <a:t>Defense-Grade Security Architecture</a:t>
+                <a:latin typeface="Arial"/>
+              </a:defRPr>
+            </a:pPr>
+            <a:r>
+              <a:t>Strong Password &amp; Recovery Security</a:t>
             </a:r>
           </a:p>
           <a:p>
@@ -8912,15 +9009,15 @@
               <a:spcBef>
                 <a:spcPts val="400"/>
               </a:spcBef>
-              <a:defRPr sz="1150">
-                <a:solidFill>
-                  <a:srgbClr val="334155"/>
-                </a:solidFill>
-                <a:latin typeface="Calibri"/>
-              </a:defRPr>
-            </a:pPr>
-            <a:r>
-              <a:t>Enforces PBKDF2-HMAC-SHA256 password salting, parameterized SQL protection, self-service unit password recovery, and append-only activity logging.</a:t>
+              <a:defRPr sz="1100">
+                <a:solidFill>
+                  <a:srgbClr val="1E293B"/>
+                </a:solidFill>
+                <a:latin typeface="Arial"/>
+              </a:defRPr>
+            </a:pPr>
+            <a:r>
+              <a:t>Passwords are encrypted using PBKDF2 hashing. Soldiers can reset forgotten passwords using their Name and Service Unit without email/SMS.</a:t>
             </a:r>
           </a:p>
         </p:txBody>
@@ -8934,7 +9031,7 @@
         <p:spPr>
           <a:xfrm>
             <a:off x="822960" y="4892040"/>
-            <a:ext cx="10545775" cy="1417320"/>
+            <a:ext cx="10545775" cy="1463040"/>
           </a:xfrm>
           <a:prstGeom prst="roundRect">
             <a:avLst/>
@@ -8944,7 +9041,7 @@
           </a:solidFill>
           <a:ln w="12700">
             <a:solidFill>
-              <a:srgbClr val="CBD5E1"/>
+              <a:srgbClr val="94A3B8"/>
             </a:solidFill>
           </a:ln>
         </p:spPr>
@@ -8978,17 +9075,19 @@
         </p:nvSpPr>
         <p:spPr>
           <a:xfrm>
-            <a:off x="1051560" y="5120640"/>
-            <a:ext cx="822960" cy="868680"/>
+            <a:off x="1051560" y="5148072"/>
+            <a:ext cx="777240" cy="868680"/>
           </a:xfrm>
           <a:prstGeom prst="roundRect">
             <a:avLst/>
           </a:prstGeom>
           <a:solidFill>
-            <a:srgbClr val="0F172A"/>
-          </a:solidFill>
-          <a:ln>
-            <a:noFill/>
+            <a:srgbClr val="F1F5F9"/>
+          </a:solidFill>
+          <a:ln w="19050">
+            <a:solidFill>
+              <a:srgbClr val="0F172A"/>
+            </a:solidFill>
           </a:ln>
         </p:spPr>
         <p:style>
@@ -9012,9 +9111,9 @@
             <a:pPr algn="ctr">
               <a:defRPr sz="2000" b="1">
                 <a:solidFill>
-                  <a:srgbClr val="FFFFFF"/>
-                </a:solidFill>
-                <a:latin typeface="Calibri"/>
+                  <a:srgbClr val="0F172A"/>
+                </a:solidFill>
+                <a:latin typeface="Arial"/>
               </a:defRPr>
             </a:pPr>
             <a:r>
@@ -9032,7 +9131,7 @@
         <p:spPr>
           <a:xfrm>
             <a:off x="2057400" y="5029200"/>
-            <a:ext cx="9144000" cy="1143000"/>
+            <a:ext cx="9144000" cy="1188720"/>
           </a:xfrm>
           <a:prstGeom prst="rect">
             <a:avLst/>
@@ -9046,15 +9145,15 @@
           <a:lstStyle/>
           <a:p>
             <a:pPr>
-              <a:defRPr sz="1400" b="1">
+              <a:defRPr sz="1350" b="1">
                 <a:solidFill>
                   <a:srgbClr val="0F172A"/>
                 </a:solidFill>
-                <a:latin typeface="Calibri"/>
-              </a:defRPr>
-            </a:pPr>
-            <a:r>
-              <a:t>Zero-Latency Multi-Language Vernacular Switcher</a:t>
+                <a:latin typeface="Arial"/>
+              </a:defRPr>
+            </a:pPr>
+            <a:r>
+              <a:t>Instant 3-Language Switcher</a:t>
             </a:r>
           </a:p>
           <a:p>
@@ -9062,15 +9161,15 @@
               <a:spcBef>
                 <a:spcPts val="400"/>
               </a:spcBef>
-              <a:defRPr sz="1150">
-                <a:solidFill>
-                  <a:srgbClr val="334155"/>
-                </a:solidFill>
-                <a:latin typeface="Calibri"/>
-              </a:defRPr>
-            </a:pPr>
-            <a:r>
-              <a:t>Client-side localization supporting English, Tamil (தமிழ்), and Hindi (हिंदी) stored in localStorage, making mental health care accessible to every jawan.</a:t>
+              <a:defRPr sz="1100">
+                <a:solidFill>
+                  <a:srgbClr val="1E293B"/>
+                </a:solidFill>
+                <a:latin typeface="Arial"/>
+              </a:defRPr>
+            </a:pPr>
+            <a:r>
+              <a:t>One-click language dropdown allows soldiers to switch between English, Tamil, and Hindi instantly for barrier-free comfort.</a:t>
             </a:r>
           </a:p>
         </p:txBody>
@@ -9083,7 +9182,7 @@
         </p:nvSpPr>
         <p:spPr>
           <a:xfrm>
-            <a:off x="822960" y="6400800"/>
+            <a:off x="822960" y="6446520"/>
             <a:ext cx="10515600" cy="320040"/>
           </a:xfrm>
           <a:prstGeom prst="rect">
@@ -9102,11 +9201,11 @@
                 <a:solidFill>
                   <a:srgbClr val="64748B"/>
                 </a:solidFill>
-                <a:latin typeface="Calibri"/>
-              </a:defRPr>
-            </a:pPr>
-            <a:r>
-              <a:t>APPS - AI Predictive Personnel Stress &amp; Welfare Monitoring Systems | Computer Science &amp; Business Systems</a:t>
+                <a:latin typeface="Arial"/>
+              </a:defRPr>
+            </a:pPr>
+            <a:r>
+              <a:t>APPS - Final Year Mini Project | DHARUN.M (CSBS) | Slide 9 of 10</a:t>
             </a:r>
           </a:p>
         </p:txBody>

</xml_diff>